<commit_message>
Add TCO slide to fuel deck — real Tata Nexon prices + EMI (8 slides)
5-yr TCO on a real Tata Nexon (petrol/diesel/CNG/EV, same model): on-road
₹12.3-16.0L, net of resale. CNG wins (₹10.0L), EV ≈ petrol (₹11.0 vs 10.9L),
diesel priciest (₹11.6L) at 12,000 km/yr. Adds monthly EMI per fuel (SBI/HDFC
~9%, EV green loan 8.55%). Prices CarWale/CarDekho Jul-2026; loan rates 2026.

Co-Authored-By: Claude Opus 4.8 <noreply@anthropic.com>
</commit_message>
<xml_diff>
--- a/docs/India_Fuel_Vehicle_Choices_2026.pptx
+++ b/docs/India_Fuel_Vehicle_Choices_2026.pptx
@@ -12,9 +12,10 @@
     <p:sldId id="260" r:id="rId6"/>
     <p:sldId id="261" r:id="rId7"/>
     <p:sldId id="262" r:id="rId8"/>
+    <p:sldId id="263" r:id="rId9"/>
   </p:sldIdLst>
   <p:notesMasterIdLst>
-    <p:notesMasterId r:id="rId9"/>
+    <p:notesMasterId r:id="rId10"/>
   </p:notesMasterIdLst>
   <p:sldSz cx="12192000" cy="6858000"/>
   <p:notesSz cx="6858000" cy="12192000"/>
@@ -426,6 +427,350 @@
 </c:chartSpace>
 </file>
 
+<file path=ppt/charts/chart2.xml><?xml version="1.0" encoding="utf-8"?>
+<c:chartSpace xmlns:c="http://schemas.openxmlformats.org/drawingml/2006/chart" xmlns:a="http://schemas.openxmlformats.org/drawingml/2006/main" xmlns:r="http://schemas.openxmlformats.org/officeDocument/2006/relationships">
+  <c:date1904 val="0"/>
+  <c:roundedCorners val="1"/>
+  <c:chart>
+    <c:autoTitleDeleted val="1"/>
+    <c:plotArea>
+      <c:layout/>
+      <c:barChart>
+        <c:barDir val="bar"/>
+        <c:grouping val="stacked"/>
+        <c:varyColors val="0"/>
+        <c:ser>
+          <c:idx val="0"/>
+          <c:order val="0"/>
+          <c:tx>
+            <c:strRef>
+              <c:f>Sheet1!$B$1</c:f>
+              <c:strCache>
+                <c:ptCount val="1"/>
+                <c:pt idx="0">
+                  <c:v>Depreciation (on-road − resale)</c:v>
+                </c:pt>
+              </c:strCache>
+            </c:strRef>
+          </c:tx>
+          <c:spPr>
+            <a:solidFill>
+              <a:srgbClr val="5D6E78"/>
+            </a:solidFill>
+            <a:effectLst/>
+          </c:spPr>
+          <c:invertIfNegative val="0"/>
+          <c:dLbls>
+            <c:numFmt formatCode="#,##0" sourceLinked="0"/>
+            <c:txPr>
+              <a:bodyPr/>
+              <a:lstStyle/>
+              <a:p>
+                <a:pPr>
+                  <a:defRPr b="0" i="0" strike="noStrike" sz="1200" u="none">
+                    <a:solidFill>
+                      <a:srgbClr val="000000"/>
+                    </a:solidFill>
+                    <a:latin typeface="Arial"/>
+                  </a:defRPr>
+                </a:pPr>
+              </a:p>
+            </c:txPr>
+            <c:showLegendKey val="0"/>
+            <c:showVal val="0"/>
+            <c:showCatName val="0"/>
+            <c:showSerName val="0"/>
+            <c:showPercent val="0"/>
+            <c:showBubbleSize val="0"/>
+            <c:showLeaderLines val="0"/>
+          </c:dLbls>
+          <c:cat>
+            <c:multiLvlStrRef>
+              <c:f>Sheet1!$A$2:$A$5</c:f>
+              <c:multiLvlStrCache>
+                <c:ptCount val="4"/>
+                <c:lvl>
+                  <c:pt idx="0">
+                    <c:v>Petrol</c:v>
+                  </c:pt>
+                  <c:pt idx="1">
+                    <c:v>CNG</c:v>
+                  </c:pt>
+                  <c:pt idx="2">
+                    <c:v>EV</c:v>
+                  </c:pt>
+                  <c:pt idx="3">
+                    <c:v>Diesel</c:v>
+                  </c:pt>
+                </c:lvl>
+              </c:multiLvlStrCache>
+            </c:multiLvlStrRef>
+          </c:cat>
+          <c:val>
+            <c:numRef>
+              <c:f>Sheet1!$B$2:$B$5</c:f>
+              <c:numCache>
+                <c:formatCode>General</c:formatCode>
+                <c:ptCount val="4"/>
+                <c:pt idx="0">
+                  <c:v>6.5</c:v>
+                </c:pt>
+                <c:pt idx="1">
+                  <c:v>7.4</c:v>
+                </c:pt>
+                <c:pt idx="2">
+                  <c:v>9.6</c:v>
+                </c:pt>
+                <c:pt idx="3">
+                  <c:v>8</c:v>
+                </c:pt>
+              </c:numCache>
+            </c:numRef>
+          </c:val>
+        </c:ser>
+        <c:ser>
+          <c:idx val="1"/>
+          <c:order val="1"/>
+          <c:tx>
+            <c:strRef>
+              <c:f>Sheet1!$C$1</c:f>
+              <c:strCache>
+                <c:ptCount val="1"/>
+                <c:pt idx="0">
+                  <c:v>Fuel + maintenance (5 yr)</c:v>
+                </c:pt>
+              </c:strCache>
+            </c:strRef>
+          </c:tx>
+          <c:spPr>
+            <a:solidFill>
+              <a:srgbClr val="2E9E6B"/>
+            </a:solidFill>
+            <a:effectLst/>
+          </c:spPr>
+          <c:invertIfNegative val="0"/>
+          <c:dLbls>
+            <c:numFmt formatCode="#,##0" sourceLinked="0"/>
+            <c:txPr>
+              <a:bodyPr/>
+              <a:lstStyle/>
+              <a:p>
+                <a:pPr>
+                  <a:defRPr b="0" i="0" strike="noStrike" sz="1200" u="none">
+                    <a:solidFill>
+                      <a:srgbClr val="000000"/>
+                    </a:solidFill>
+                    <a:latin typeface="Arial"/>
+                  </a:defRPr>
+                </a:pPr>
+              </a:p>
+            </c:txPr>
+            <c:showLegendKey val="0"/>
+            <c:showVal val="0"/>
+            <c:showCatName val="0"/>
+            <c:showSerName val="0"/>
+            <c:showPercent val="0"/>
+            <c:showBubbleSize val="0"/>
+            <c:showLeaderLines val="0"/>
+          </c:dLbls>
+          <c:cat>
+            <c:multiLvlStrRef>
+              <c:f>Sheet1!$A$2:$A$5</c:f>
+              <c:multiLvlStrCache>
+                <c:ptCount val="4"/>
+                <c:lvl>
+                  <c:pt idx="0">
+                    <c:v>Petrol</c:v>
+                  </c:pt>
+                  <c:pt idx="1">
+                    <c:v>CNG</c:v>
+                  </c:pt>
+                  <c:pt idx="2">
+                    <c:v>EV</c:v>
+                  </c:pt>
+                  <c:pt idx="3">
+                    <c:v>Diesel</c:v>
+                  </c:pt>
+                </c:lvl>
+              </c:multiLvlStrCache>
+            </c:multiLvlStrRef>
+          </c:cat>
+          <c:val>
+            <c:numRef>
+              <c:f>Sheet1!$C$2:$C$5</c:f>
+              <c:numCache>
+                <c:formatCode>General</c:formatCode>
+                <c:ptCount val="4"/>
+                <c:pt idx="0">
+                  <c:v>4.35</c:v>
+                </c:pt>
+                <c:pt idx="1">
+                  <c:v>2.6</c:v>
+                </c:pt>
+                <c:pt idx="2">
+                  <c:v>1.4</c:v>
+                </c:pt>
+                <c:pt idx="3">
+                  <c:v>3.6</c:v>
+                </c:pt>
+              </c:numCache>
+            </c:numRef>
+          </c:val>
+        </c:ser>
+        <c:dLbls>
+          <c:numFmt formatCode="#,##0" sourceLinked="0"/>
+          <c:txPr>
+            <a:bodyPr/>
+            <a:lstStyle/>
+            <a:p>
+              <a:pPr>
+                <a:defRPr b="0" i="0" strike="noStrike" sz="1200" u="none">
+                  <a:solidFill>
+                    <a:srgbClr val="000000"/>
+                  </a:solidFill>
+                  <a:latin typeface="Arial"/>
+                </a:defRPr>
+              </a:pPr>
+            </a:p>
+          </c:txPr>
+          <c:showLegendKey val="0"/>
+          <c:showVal val="0"/>
+          <c:showCatName val="0"/>
+          <c:showSerName val="0"/>
+          <c:showPercent val="0"/>
+          <c:showBubbleSize val="0"/>
+          <c:showLeaderLines val="0"/>
+        </c:dLbls>
+        <c:gapWidth val="52"/>
+        <c:overlap val="100"/>
+        <c:axId val="2094734554"/>
+        <c:axId val="2094734552"/>
+        <c:axId val="2094734556"/>
+      </c:barChart>
+      <c:catAx>
+        <c:axId val="2094734554"/>
+        <c:scaling>
+          <c:orientation val="minMax"/>
+        </c:scaling>
+        <c:delete val="0"/>
+        <c:axPos val="l"/>
+        <c:numFmt formatCode="General" sourceLinked="1"/>
+        <c:majorTickMark val="out"/>
+        <c:minorTickMark val="none"/>
+        <c:tickLblPos val="nextTo"/>
+        <c:spPr>
+          <a:ln w="12700" cap="flat">
+            <a:solidFill>
+              <a:srgbClr val="888888"/>
+            </a:solidFill>
+            <a:prstDash val="solid"/>
+            <a:round/>
+          </a:ln>
+        </c:spPr>
+        <c:txPr>
+          <a:bodyPr/>
+          <a:lstStyle/>
+          <a:p>
+            <a:pPr>
+              <a:defRPr sz="1300" b="0" i="0" u="none" strike="noStrike">
+                <a:solidFill>
+                  <a:srgbClr val="15271F"/>
+                </a:solidFill>
+                <a:latin typeface="Calibri"/>
+              </a:defRPr>
+            </a:pPr>
+            <a:endParaRPr lang="en-US"/>
+          </a:p>
+        </c:txPr>
+        <c:crossAx val="2094734552"/>
+        <c:crosses val="autoZero"/>
+        <c:auto val="1"/>
+        <c:lblAlgn val="ctr"/>
+        <c:noMultiLvlLbl val="1"/>
+      </c:catAx>
+      <c:valAx>
+        <c:axId val="2094734552"/>
+        <c:scaling>
+          <c:orientation val="minMax"/>
+        </c:scaling>
+        <c:delete val="1"/>
+        <c:axPos val="b"/>
+        <c:numFmt formatCode="General" sourceLinked="0"/>
+        <c:majorTickMark val="out"/>
+        <c:minorTickMark val="none"/>
+        <c:tickLblPos val="low"/>
+        <c:spPr>
+          <a:ln w="12700" cap="flat">
+            <a:solidFill>
+              <a:srgbClr val="888888"/>
+            </a:solidFill>
+            <a:prstDash val="solid"/>
+            <a:round/>
+          </a:ln>
+        </c:spPr>
+        <c:txPr>
+          <a:bodyPr/>
+          <a:lstStyle/>
+          <a:p>
+            <a:pPr>
+              <a:defRPr sz="1200" b="0" i="0" u="none" strike="noStrike">
+                <a:solidFill>
+                  <a:srgbClr val="000000"/>
+                </a:solidFill>
+                <a:latin typeface="Arial"/>
+              </a:defRPr>
+            </a:pPr>
+            <a:endParaRPr lang="en-US"/>
+          </a:p>
+        </c:txPr>
+        <c:crossAx val="2094734554"/>
+        <c:crosses val="autoZero"/>
+        <c:crossBetween val="between"/>
+      </c:valAx>
+      <c:spPr>
+        <a:noFill/>
+        <a:ln>
+          <a:noFill/>
+        </a:ln>
+        <a:effectLst/>
+      </c:spPr>
+    </c:plotArea>
+    <c:legend>
+      <c:legendPos val="t"/>
+      <c:overlay val="0"/>
+      <c:txPr>
+        <a:bodyPr/>
+        <a:lstStyle/>
+        <a:p>
+          <a:pPr>
+            <a:defRPr sz="1100">
+              <a:solidFill>
+                <a:srgbClr val="15271F"/>
+              </a:solidFill>
+              <a:latin typeface="Calibri"/>
+              <a:cs typeface="Calibri"/>
+            </a:defRPr>
+          </a:pPr>
+          <a:endParaRPr lang="en-US"/>
+        </a:p>
+      </c:txPr>
+    </c:legend>
+    <c:plotVisOnly val="1"/>
+    <c:dispBlanksAs val="span"/>
+  </c:chart>
+  <c:spPr>
+    <a:noFill/>
+    <a:ln>
+      <a:noFill/>
+    </a:ln>
+    <a:effectLst/>
+  </c:spPr>
+  <c:externalData r:id="rId1">
+    <c:autoUpdate val="0"/>
+  </c:externalData>
+</c:chartSpace>
+</file>
+
 <file path=ppt/notesMasters/notesMaster1.xml><?xml version="1.0" encoding="utf-8"?>
 <p:notesMaster xmlns:a="http://schemas.openxmlformats.org/drawingml/2006/main" xmlns:r="http://schemas.openxmlformats.org/officeDocument/2006/relationships" xmlns:p="http://schemas.openxmlformats.org/presentationml/2006/main">
   <p:cSld>
@@ -1373,6 +1718,94 @@
             <a:fld id="{F7021451-1387-4CA6-816F-3879F97B5CBC}" type="slidenum">
               <a:rPr lang="en-US"/>
               <a:t>7</a:t>
+            </a:fld>
+            <a:endParaRPr lang="en-US"/>
+          </a:p>
+        </p:txBody>
+      </p:sp>
+    </p:spTree>
+    <p:extLst>
+      <p:ext uri="{BB962C8B-B14F-4D97-AF65-F5344CB8AC3E}">
+        <p14:creationId xmlns:p14="http://schemas.microsoft.com/office/powerpoint/2010/main" val="1024086991"/>
+      </p:ext>
+    </p:extLst>
+  </p:cSld>
+  <p:clrMapOvr>
+    <a:masterClrMapping/>
+  </p:clrMapOvr>
+</p:notes>
+</file>
+
+<file path=ppt/notesSlides/notesSlide8.xml><?xml version="1.0" encoding="utf-8"?>
+<p:notes xmlns:a="http://schemas.openxmlformats.org/drawingml/2006/main" xmlns:r="http://schemas.openxmlformats.org/officeDocument/2006/relationships" xmlns:p="http://schemas.openxmlformats.org/presentationml/2006/main">
+  <p:cSld>
+    <p:spTree>
+      <p:nvGrpSpPr>
+        <p:cNvPr id="1" name=""/>
+        <p:cNvGrpSpPr/>
+        <p:nvPr/>
+      </p:nvGrpSpPr>
+      <p:grpSpPr>
+        <a:xfrm>
+          <a:off x="0" y="0"/>
+          <a:ext cx="0" cy="0"/>
+          <a:chOff x="0" y="0"/>
+          <a:chExt cx="0" cy="0"/>
+        </a:xfrm>
+      </p:grpSpPr>
+      <p:sp>
+        <p:nvSpPr>
+          <p:cNvPr id="2" name="Slide Image Placeholder 1"/>
+          <p:cNvSpPr>
+            <a:spLocks noGrp="1" noRot="1" noChangeAspect="1"/>
+          </p:cNvSpPr>
+          <p:nvPr>
+            <p:ph type="sldImg"/>
+          </p:nvPr>
+        </p:nvSpPr>
+        <p:spPr/>
+      </p:sp>
+      <p:sp>
+        <p:nvSpPr>
+          <p:cNvPr id="3" name="Notes Placeholder 2"/>
+          <p:cNvSpPr>
+            <a:spLocks noGrp="1"/>
+          </p:cNvSpPr>
+          <p:nvPr>
+            <p:ph type="body" idx="1"/>
+          </p:nvPr>
+        </p:nvSpPr>
+        <p:spPr/>
+        <p:txBody>
+          <a:bodyPr/>
+          <a:lstStyle/>
+          <a:p>
+            <a:r>
+              <a:rPr lang="en-US" dirty="0"/>
+              <a:t/>
+            </a:r>
+            <a:endParaRPr lang="en-US" dirty="0"/>
+          </a:p>
+        </p:txBody>
+      </p:sp>
+      <p:sp>
+        <p:nvSpPr>
+          <p:cNvPr id="4" name="Slide Number Placeholder 3"/>
+          <p:cNvSpPr>
+            <a:spLocks noGrp="1"/>
+          </p:cNvSpPr>
+          <p:nvPr>
+            <p:ph type="sldNum" sz="quarter" idx="10"/>
+          </p:nvPr>
+        </p:nvSpPr>
+        <p:spPr/>
+        <p:txBody>
+          <a:bodyPr/>
+          <a:lstStyle/>
+          <a:p>
+            <a:fld id="{F7021451-1387-4CA6-816F-3879F97B5CBC}" type="slidenum">
+              <a:rPr lang="en-US"/>
+              <a:t>8</a:t>
             </a:fld>
             <a:endParaRPr lang="en-US"/>
           </a:p>
@@ -7306,6 +7739,862 @@
     <p:bg>
       <p:bgPr>
         <a:solidFill>
+          <a:srgbClr val="F7F9F7"/>
+        </a:solidFill>
+      </p:bgPr>
+    </p:bg>
+    <p:spTree>
+      <p:nvGrpSpPr>
+        <p:cNvPr id="1" name=""/>
+        <p:cNvGrpSpPr/>
+        <p:nvPr/>
+      </p:nvGrpSpPr>
+      <p:grpSpPr>
+        <a:xfrm>
+          <a:off x="0" y="0"/>
+          <a:ext cx="0" cy="0"/>
+          <a:chOff x="0" y="0"/>
+          <a:chExt cx="0" cy="0"/>
+        </a:xfrm>
+      </p:grpSpPr>
+      <p:sp>
+        <p:nvSpPr>
+          <p:cNvPr id="2" name="Text 0"/>
+          <p:cNvSpPr/>
+          <p:nvPr/>
+        </p:nvSpPr>
+        <p:spPr>
+          <a:xfrm>
+            <a:off x="548640" y="502920"/>
+            <a:ext cx="10058400" cy="274320"/>
+          </a:xfrm>
+          <a:prstGeom prst="rect">
+            <a:avLst/>
+          </a:prstGeom>
+          <a:noFill/>
+          <a:ln/>
+        </p:spPr>
+        <p:txBody>
+          <a:bodyPr wrap="square" rtlCol="0" anchor="ctr"/>
+          <a:lstStyle/>
+          <a:p>
+            <a:pPr indent="0" marL="0">
+              <a:buNone/>
+            </a:pPr>
+            <a:r>
+              <a:rPr lang="en-US" sz="1200" b="1" spc="300" kern="0" dirty="0">
+                <a:solidFill>
+                  <a:srgbClr val="2E8FA0"/>
+                </a:solidFill>
+                <a:latin typeface="Calibri" pitchFamily="34" charset="0"/>
+                <a:ea typeface="Calibri" pitchFamily="34" charset="-122"/>
+                <a:cs typeface="Calibri" pitchFamily="34" charset="-120"/>
+              </a:rPr>
+              <a:t>TOTAL COST OF OWNERSHIP</a:t>
+            </a:r>
+            <a:endParaRPr lang="en-US" sz="1200" dirty="0"/>
+          </a:p>
+        </p:txBody>
+      </p:sp>
+      <p:sp>
+        <p:nvSpPr>
+          <p:cNvPr id="3" name="Text 1"/>
+          <p:cNvSpPr/>
+          <p:nvPr/>
+        </p:nvSpPr>
+        <p:spPr>
+          <a:xfrm>
+            <a:off x="548640" y="777240"/>
+            <a:ext cx="10972800" cy="1005840"/>
+          </a:xfrm>
+          <a:prstGeom prst="rect">
+            <a:avLst/>
+          </a:prstGeom>
+          <a:noFill/>
+          <a:ln/>
+        </p:spPr>
+        <p:txBody>
+          <a:bodyPr wrap="square" rtlCol="0" anchor="ctr"/>
+          <a:lstStyle/>
+          <a:p>
+            <a:pPr indent="0" marL="0">
+              <a:lnSpc>
+                <a:spcPct val="98000"/>
+              </a:lnSpc>
+              <a:buNone/>
+            </a:pPr>
+            <a:r>
+              <a:rPr lang="en-US" sz="3400" b="1" dirty="0">
+                <a:solidFill>
+                  <a:srgbClr val="15271F"/>
+                </a:solidFill>
+                <a:latin typeface="Cambria" pitchFamily="34" charset="0"/>
+                <a:ea typeface="Cambria" pitchFamily="34" charset="-122"/>
+                <a:cs typeface="Cambria" pitchFamily="34" charset="-120"/>
+              </a:rPr>
+              <a:t>5 years on a real Tata Nexon — all four fuels</a:t>
+            </a:r>
+            <a:endParaRPr lang="en-US" sz="3400" dirty="0"/>
+          </a:p>
+        </p:txBody>
+      </p:sp>
+      <p:sp>
+        <p:nvSpPr>
+          <p:cNvPr id="4" name="Text 2"/>
+          <p:cNvSpPr/>
+          <p:nvPr/>
+        </p:nvSpPr>
+        <p:spPr>
+          <a:xfrm>
+            <a:off x="548640" y="1600200"/>
+            <a:ext cx="11064240" cy="365760"/>
+          </a:xfrm>
+          <a:prstGeom prst="rect">
+            <a:avLst/>
+          </a:prstGeom>
+          <a:noFill/>
+          <a:ln/>
+        </p:spPr>
+        <p:txBody>
+          <a:bodyPr wrap="square" rtlCol="0" anchor="ctr"/>
+          <a:lstStyle/>
+          <a:p>
+            <a:pPr indent="0" marL="0">
+              <a:buNone/>
+            </a:pPr>
+            <a:r>
+              <a:rPr lang="en-US" sz="1400" dirty="0">
+                <a:solidFill>
+                  <a:srgbClr val="5E6E66"/>
+                </a:solidFill>
+                <a:latin typeface="Calibri" pitchFamily="34" charset="0"/>
+                <a:ea typeface="Calibri" pitchFamily="34" charset="-122"/>
+                <a:cs typeface="Calibri" pitchFamily="34" charset="-120"/>
+              </a:rPr>
+              <a:t>Same model, on-road: petrol ₹12.3L · CNG ₹13.3L · diesel ₹14.5L · EV ₹16.0L. 12,000 km/yr, net of resale.</a:t>
+            </a:r>
+            <a:endParaRPr lang="en-US" sz="1400" dirty="0"/>
+          </a:p>
+        </p:txBody>
+      </p:sp>
+      <p:graphicFrame>
+        <p:nvGraphicFramePr>
+          <p:cNvPr id="5" name="Chart 0" descr=""/>
+          <p:cNvGraphicFramePr/>
+          <p:nvPr/>
+        </p:nvGraphicFramePr>
+        <p:xfrm>
+          <a:off x="457200" y="2057400"/>
+          <a:ext cx="7818120" cy="3383280"/>
+        </p:xfrm>
+        <a:graphic xmlns:a="http://schemas.openxmlformats.org/drawingml/2006/main">
+          <a:graphicData uri="http://schemas.openxmlformats.org/drawingml/2006/chart">
+            <c:chart xmlns:c="http://schemas.openxmlformats.org/drawingml/2006/chart" r:id="rId1"/>
+          </a:graphicData>
+        </a:graphic>
+      </p:graphicFrame>
+      <p:sp>
+        <p:nvSpPr>
+          <p:cNvPr id="6" name="Shape 3"/>
+          <p:cNvSpPr/>
+          <p:nvPr/>
+        </p:nvSpPr>
+        <p:spPr>
+          <a:xfrm>
+            <a:off x="8503920" y="2057400"/>
+            <a:ext cx="3154680" cy="3383280"/>
+          </a:xfrm>
+          <a:prstGeom prst="roundRect">
+            <a:avLst>
+              <a:gd name="adj" fmla="val 2609"/>
+            </a:avLst>
+          </a:prstGeom>
+          <a:solidFill>
+            <a:srgbClr val="15271F"/>
+          </a:solidFill>
+          <a:ln/>
+        </p:spPr>
+      </p:sp>
+      <p:sp>
+        <p:nvSpPr>
+          <p:cNvPr id="7" name="Text 4"/>
+          <p:cNvSpPr/>
+          <p:nvPr/>
+        </p:nvSpPr>
+        <p:spPr>
+          <a:xfrm>
+            <a:off x="8732520" y="2240280"/>
+            <a:ext cx="2834640" cy="365760"/>
+          </a:xfrm>
+          <a:prstGeom prst="rect">
+            <a:avLst/>
+          </a:prstGeom>
+          <a:noFill/>
+          <a:ln/>
+        </p:spPr>
+        <p:txBody>
+          <a:bodyPr wrap="square" rtlCol="0" anchor="ctr"/>
+          <a:lstStyle/>
+          <a:p>
+            <a:pPr indent="0" marL="0">
+              <a:buNone/>
+            </a:pPr>
+            <a:r>
+              <a:rPr lang="en-US" sz="1500" b="1" dirty="0">
+                <a:solidFill>
+                  <a:srgbClr val="2E9E6B"/>
+                </a:solidFill>
+                <a:latin typeface="Cambria" pitchFamily="34" charset="0"/>
+                <a:ea typeface="Cambria" pitchFamily="34" charset="-122"/>
+                <a:cs typeface="Cambria" pitchFamily="34" charset="-120"/>
+              </a:rPr>
+              <a:t>5-yr total  ·  EMI/month</a:t>
+            </a:r>
+            <a:endParaRPr lang="en-US" sz="1500" dirty="0"/>
+          </a:p>
+        </p:txBody>
+      </p:sp>
+      <p:sp>
+        <p:nvSpPr>
+          <p:cNvPr id="8" name="Text 5"/>
+          <p:cNvSpPr/>
+          <p:nvPr/>
+        </p:nvSpPr>
+        <p:spPr>
+          <a:xfrm>
+            <a:off x="8732520" y="2788920"/>
+            <a:ext cx="1234440" cy="502920"/>
+          </a:xfrm>
+          <a:prstGeom prst="rect">
+            <a:avLst/>
+          </a:prstGeom>
+          <a:noFill/>
+          <a:ln/>
+        </p:spPr>
+        <p:txBody>
+          <a:bodyPr wrap="square" lIns="0" tIns="0" rIns="0" bIns="0" rtlCol="0" anchor="ctr"/>
+          <a:lstStyle/>
+          <a:p>
+            <a:pPr indent="0" marL="0">
+              <a:buNone/>
+            </a:pPr>
+            <a:r>
+              <a:rPr lang="en-US" sz="1400" b="1" dirty="0">
+                <a:solidFill>
+                  <a:srgbClr val="E8F1EC"/>
+                </a:solidFill>
+                <a:latin typeface="Calibri" pitchFamily="34" charset="0"/>
+                <a:ea typeface="Calibri" pitchFamily="34" charset="-122"/>
+                <a:cs typeface="Calibri" pitchFamily="34" charset="-120"/>
+              </a:rPr>
+              <a:t>CNG</a:t>
+            </a:r>
+            <a:endParaRPr lang="en-US" sz="1400" dirty="0"/>
+          </a:p>
+        </p:txBody>
+      </p:sp>
+      <p:sp>
+        <p:nvSpPr>
+          <p:cNvPr id="9" name="Text 6"/>
+          <p:cNvSpPr/>
+          <p:nvPr/>
+        </p:nvSpPr>
+        <p:spPr>
+          <a:xfrm>
+            <a:off x="9601200" y="2788920"/>
+            <a:ext cx="960120" cy="502920"/>
+          </a:xfrm>
+          <a:prstGeom prst="rect">
+            <a:avLst/>
+          </a:prstGeom>
+          <a:noFill/>
+          <a:ln/>
+        </p:spPr>
+        <p:txBody>
+          <a:bodyPr wrap="square" lIns="0" tIns="0" rIns="0" bIns="0" rtlCol="0" anchor="ctr"/>
+          <a:lstStyle/>
+          <a:p>
+            <a:pPr algn="r" indent="0" marL="0">
+              <a:buNone/>
+            </a:pPr>
+            <a:r>
+              <a:rPr lang="en-US" sz="1600" b="1" dirty="0">
+                <a:solidFill>
+                  <a:srgbClr val="2E9E6B"/>
+                </a:solidFill>
+                <a:latin typeface="Cambria" pitchFamily="34" charset="0"/>
+                <a:ea typeface="Cambria" pitchFamily="34" charset="-122"/>
+                <a:cs typeface="Cambria" pitchFamily="34" charset="-120"/>
+              </a:rPr>
+              <a:t>₹10.0L</a:t>
+            </a:r>
+            <a:endParaRPr lang="en-US" sz="1600" dirty="0"/>
+          </a:p>
+        </p:txBody>
+      </p:sp>
+      <p:sp>
+        <p:nvSpPr>
+          <p:cNvPr id="10" name="Text 7"/>
+          <p:cNvSpPr/>
+          <p:nvPr/>
+        </p:nvSpPr>
+        <p:spPr>
+          <a:xfrm>
+            <a:off x="10607040" y="2788920"/>
+            <a:ext cx="960120" cy="502920"/>
+          </a:xfrm>
+          <a:prstGeom prst="rect">
+            <a:avLst/>
+          </a:prstGeom>
+          <a:noFill/>
+          <a:ln/>
+        </p:spPr>
+        <p:txBody>
+          <a:bodyPr wrap="square" lIns="0" tIns="0" rIns="0" bIns="0" rtlCol="0" anchor="ctr"/>
+          <a:lstStyle/>
+          <a:p>
+            <a:pPr algn="r" indent="0" marL="0">
+              <a:buNone/>
+            </a:pPr>
+            <a:r>
+              <a:rPr lang="en-US" sz="1250" dirty="0">
+                <a:solidFill>
+                  <a:srgbClr val="9DB4A9"/>
+                </a:solidFill>
+                <a:latin typeface="Calibri" pitchFamily="34" charset="0"/>
+                <a:ea typeface="Calibri" pitchFamily="34" charset="-122"/>
+                <a:cs typeface="Calibri" pitchFamily="34" charset="-120"/>
+              </a:rPr>
+              <a:t>₹27.6k</a:t>
+            </a:r>
+            <a:endParaRPr lang="en-US" sz="1250" dirty="0"/>
+          </a:p>
+        </p:txBody>
+      </p:sp>
+      <p:sp>
+        <p:nvSpPr>
+          <p:cNvPr id="11" name="Text 8"/>
+          <p:cNvSpPr/>
+          <p:nvPr/>
+        </p:nvSpPr>
+        <p:spPr>
+          <a:xfrm>
+            <a:off x="8732520" y="3355848"/>
+            <a:ext cx="1234440" cy="502920"/>
+          </a:xfrm>
+          <a:prstGeom prst="rect">
+            <a:avLst/>
+          </a:prstGeom>
+          <a:noFill/>
+          <a:ln/>
+        </p:spPr>
+        <p:txBody>
+          <a:bodyPr wrap="square" lIns="0" tIns="0" rIns="0" bIns="0" rtlCol="0" anchor="ctr"/>
+          <a:lstStyle/>
+          <a:p>
+            <a:pPr indent="0" marL="0">
+              <a:buNone/>
+            </a:pPr>
+            <a:r>
+              <a:rPr lang="en-US" sz="1400" b="1" dirty="0">
+                <a:solidFill>
+                  <a:srgbClr val="E8F1EC"/>
+                </a:solidFill>
+                <a:latin typeface="Calibri" pitchFamily="34" charset="0"/>
+                <a:ea typeface="Calibri" pitchFamily="34" charset="-122"/>
+                <a:cs typeface="Calibri" pitchFamily="34" charset="-120"/>
+              </a:rPr>
+              <a:t>Petrol</a:t>
+            </a:r>
+            <a:endParaRPr lang="en-US" sz="1400" dirty="0"/>
+          </a:p>
+        </p:txBody>
+      </p:sp>
+      <p:sp>
+        <p:nvSpPr>
+          <p:cNvPr id="12" name="Text 9"/>
+          <p:cNvSpPr/>
+          <p:nvPr/>
+        </p:nvSpPr>
+        <p:spPr>
+          <a:xfrm>
+            <a:off x="9601200" y="3355848"/>
+            <a:ext cx="960120" cy="502920"/>
+          </a:xfrm>
+          <a:prstGeom prst="rect">
+            <a:avLst/>
+          </a:prstGeom>
+          <a:noFill/>
+          <a:ln/>
+        </p:spPr>
+        <p:txBody>
+          <a:bodyPr wrap="square" lIns="0" tIns="0" rIns="0" bIns="0" rtlCol="0" anchor="ctr"/>
+          <a:lstStyle/>
+          <a:p>
+            <a:pPr algn="r" indent="0" marL="0">
+              <a:buNone/>
+            </a:pPr>
+            <a:r>
+              <a:rPr lang="en-US" sz="1600" b="1" dirty="0">
+                <a:solidFill>
+                  <a:srgbClr val="FFFFFF"/>
+                </a:solidFill>
+                <a:latin typeface="Cambria" pitchFamily="34" charset="0"/>
+                <a:ea typeface="Cambria" pitchFamily="34" charset="-122"/>
+                <a:cs typeface="Cambria" pitchFamily="34" charset="-120"/>
+              </a:rPr>
+              <a:t>₹10.9L</a:t>
+            </a:r>
+            <a:endParaRPr lang="en-US" sz="1600" dirty="0"/>
+          </a:p>
+        </p:txBody>
+      </p:sp>
+      <p:sp>
+        <p:nvSpPr>
+          <p:cNvPr id="13" name="Text 10"/>
+          <p:cNvSpPr/>
+          <p:nvPr/>
+        </p:nvSpPr>
+        <p:spPr>
+          <a:xfrm>
+            <a:off x="10607040" y="3355848"/>
+            <a:ext cx="960120" cy="502920"/>
+          </a:xfrm>
+          <a:prstGeom prst="rect">
+            <a:avLst/>
+          </a:prstGeom>
+          <a:noFill/>
+          <a:ln/>
+        </p:spPr>
+        <p:txBody>
+          <a:bodyPr wrap="square" lIns="0" tIns="0" rIns="0" bIns="0" rtlCol="0" anchor="ctr"/>
+          <a:lstStyle/>
+          <a:p>
+            <a:pPr algn="r" indent="0" marL="0">
+              <a:buNone/>
+            </a:pPr>
+            <a:r>
+              <a:rPr lang="en-US" sz="1250" dirty="0">
+                <a:solidFill>
+                  <a:srgbClr val="9DB4A9"/>
+                </a:solidFill>
+                <a:latin typeface="Calibri" pitchFamily="34" charset="0"/>
+                <a:ea typeface="Calibri" pitchFamily="34" charset="-122"/>
+                <a:cs typeface="Calibri" pitchFamily="34" charset="-120"/>
+              </a:rPr>
+              <a:t>₹25.5k</a:t>
+            </a:r>
+            <a:endParaRPr lang="en-US" sz="1250" dirty="0"/>
+          </a:p>
+        </p:txBody>
+      </p:sp>
+      <p:sp>
+        <p:nvSpPr>
+          <p:cNvPr id="14" name="Text 11"/>
+          <p:cNvSpPr/>
+          <p:nvPr/>
+        </p:nvSpPr>
+        <p:spPr>
+          <a:xfrm>
+            <a:off x="8732520" y="3922776"/>
+            <a:ext cx="1234440" cy="502920"/>
+          </a:xfrm>
+          <a:prstGeom prst="rect">
+            <a:avLst/>
+          </a:prstGeom>
+          <a:noFill/>
+          <a:ln/>
+        </p:spPr>
+        <p:txBody>
+          <a:bodyPr wrap="square" lIns="0" tIns="0" rIns="0" bIns="0" rtlCol="0" anchor="ctr"/>
+          <a:lstStyle/>
+          <a:p>
+            <a:pPr indent="0" marL="0">
+              <a:buNone/>
+            </a:pPr>
+            <a:r>
+              <a:rPr lang="en-US" sz="1400" b="1" dirty="0">
+                <a:solidFill>
+                  <a:srgbClr val="E8F1EC"/>
+                </a:solidFill>
+                <a:latin typeface="Calibri" pitchFamily="34" charset="0"/>
+                <a:ea typeface="Calibri" pitchFamily="34" charset="-122"/>
+                <a:cs typeface="Calibri" pitchFamily="34" charset="-120"/>
+              </a:rPr>
+              <a:t>EV</a:t>
+            </a:r>
+            <a:endParaRPr lang="en-US" sz="1400" dirty="0"/>
+          </a:p>
+        </p:txBody>
+      </p:sp>
+      <p:sp>
+        <p:nvSpPr>
+          <p:cNvPr id="15" name="Text 12"/>
+          <p:cNvSpPr/>
+          <p:nvPr/>
+        </p:nvSpPr>
+        <p:spPr>
+          <a:xfrm>
+            <a:off x="9601200" y="3922776"/>
+            <a:ext cx="960120" cy="502920"/>
+          </a:xfrm>
+          <a:prstGeom prst="rect">
+            <a:avLst/>
+          </a:prstGeom>
+          <a:noFill/>
+          <a:ln/>
+        </p:spPr>
+        <p:txBody>
+          <a:bodyPr wrap="square" lIns="0" tIns="0" rIns="0" bIns="0" rtlCol="0" anchor="ctr"/>
+          <a:lstStyle/>
+          <a:p>
+            <a:pPr algn="r" indent="0" marL="0">
+              <a:buNone/>
+            </a:pPr>
+            <a:r>
+              <a:rPr lang="en-US" sz="1600" b="1" dirty="0">
+                <a:solidFill>
+                  <a:srgbClr val="D2892C"/>
+                </a:solidFill>
+                <a:latin typeface="Cambria" pitchFamily="34" charset="0"/>
+                <a:ea typeface="Cambria" pitchFamily="34" charset="-122"/>
+                <a:cs typeface="Cambria" pitchFamily="34" charset="-120"/>
+              </a:rPr>
+              <a:t>₹11.0L</a:t>
+            </a:r>
+            <a:endParaRPr lang="en-US" sz="1600" dirty="0"/>
+          </a:p>
+        </p:txBody>
+      </p:sp>
+      <p:sp>
+        <p:nvSpPr>
+          <p:cNvPr id="16" name="Text 13"/>
+          <p:cNvSpPr/>
+          <p:nvPr/>
+        </p:nvSpPr>
+        <p:spPr>
+          <a:xfrm>
+            <a:off x="10607040" y="3922776"/>
+            <a:ext cx="960120" cy="502920"/>
+          </a:xfrm>
+          <a:prstGeom prst="rect">
+            <a:avLst/>
+          </a:prstGeom>
+          <a:noFill/>
+          <a:ln/>
+        </p:spPr>
+        <p:txBody>
+          <a:bodyPr wrap="square" lIns="0" tIns="0" rIns="0" bIns="0" rtlCol="0" anchor="ctr"/>
+          <a:lstStyle/>
+          <a:p>
+            <a:pPr algn="r" indent="0" marL="0">
+              <a:buNone/>
+            </a:pPr>
+            <a:r>
+              <a:rPr lang="en-US" sz="1250" dirty="0">
+                <a:solidFill>
+                  <a:srgbClr val="9DB4A9"/>
+                </a:solidFill>
+                <a:latin typeface="Calibri" pitchFamily="34" charset="0"/>
+                <a:ea typeface="Calibri" pitchFamily="34" charset="-122"/>
+                <a:cs typeface="Calibri" pitchFamily="34" charset="-120"/>
+              </a:rPr>
+              <a:t>₹32.9k</a:t>
+            </a:r>
+            <a:endParaRPr lang="en-US" sz="1250" dirty="0"/>
+          </a:p>
+        </p:txBody>
+      </p:sp>
+      <p:sp>
+        <p:nvSpPr>
+          <p:cNvPr id="17" name="Text 14"/>
+          <p:cNvSpPr/>
+          <p:nvPr/>
+        </p:nvSpPr>
+        <p:spPr>
+          <a:xfrm>
+            <a:off x="8732520" y="4489704"/>
+            <a:ext cx="1234440" cy="502920"/>
+          </a:xfrm>
+          <a:prstGeom prst="rect">
+            <a:avLst/>
+          </a:prstGeom>
+          <a:noFill/>
+          <a:ln/>
+        </p:spPr>
+        <p:txBody>
+          <a:bodyPr wrap="square" lIns="0" tIns="0" rIns="0" bIns="0" rtlCol="0" anchor="ctr"/>
+          <a:lstStyle/>
+          <a:p>
+            <a:pPr indent="0" marL="0">
+              <a:buNone/>
+            </a:pPr>
+            <a:r>
+              <a:rPr lang="en-US" sz="1400" b="1" dirty="0">
+                <a:solidFill>
+                  <a:srgbClr val="E8F1EC"/>
+                </a:solidFill>
+                <a:latin typeface="Calibri" pitchFamily="34" charset="0"/>
+                <a:ea typeface="Calibri" pitchFamily="34" charset="-122"/>
+                <a:cs typeface="Calibri" pitchFamily="34" charset="-120"/>
+              </a:rPr>
+              <a:t>Diesel</a:t>
+            </a:r>
+            <a:endParaRPr lang="en-US" sz="1400" dirty="0"/>
+          </a:p>
+        </p:txBody>
+      </p:sp>
+      <p:sp>
+        <p:nvSpPr>
+          <p:cNvPr id="18" name="Text 15"/>
+          <p:cNvSpPr/>
+          <p:nvPr/>
+        </p:nvSpPr>
+        <p:spPr>
+          <a:xfrm>
+            <a:off x="9601200" y="4489704"/>
+            <a:ext cx="960120" cy="502920"/>
+          </a:xfrm>
+          <a:prstGeom prst="rect">
+            <a:avLst/>
+          </a:prstGeom>
+          <a:noFill/>
+          <a:ln/>
+        </p:spPr>
+        <p:txBody>
+          <a:bodyPr wrap="square" lIns="0" tIns="0" rIns="0" bIns="0" rtlCol="0" anchor="ctr"/>
+          <a:lstStyle/>
+          <a:p>
+            <a:pPr algn="r" indent="0" marL="0">
+              <a:buNone/>
+            </a:pPr>
+            <a:r>
+              <a:rPr lang="en-US" sz="1600" b="1" dirty="0">
+                <a:solidFill>
+                  <a:srgbClr val="FFFFFF"/>
+                </a:solidFill>
+                <a:latin typeface="Cambria" pitchFamily="34" charset="0"/>
+                <a:ea typeface="Cambria" pitchFamily="34" charset="-122"/>
+                <a:cs typeface="Cambria" pitchFamily="34" charset="-120"/>
+              </a:rPr>
+              <a:t>₹11.6L</a:t>
+            </a:r>
+            <a:endParaRPr lang="en-US" sz="1600" dirty="0"/>
+          </a:p>
+        </p:txBody>
+      </p:sp>
+      <p:sp>
+        <p:nvSpPr>
+          <p:cNvPr id="19" name="Text 16"/>
+          <p:cNvSpPr/>
+          <p:nvPr/>
+        </p:nvSpPr>
+        <p:spPr>
+          <a:xfrm>
+            <a:off x="10607040" y="4489704"/>
+            <a:ext cx="960120" cy="502920"/>
+          </a:xfrm>
+          <a:prstGeom prst="rect">
+            <a:avLst/>
+          </a:prstGeom>
+          <a:noFill/>
+          <a:ln/>
+        </p:spPr>
+        <p:txBody>
+          <a:bodyPr wrap="square" lIns="0" tIns="0" rIns="0" bIns="0" rtlCol="0" anchor="ctr"/>
+          <a:lstStyle/>
+          <a:p>
+            <a:pPr algn="r" indent="0" marL="0">
+              <a:buNone/>
+            </a:pPr>
+            <a:r>
+              <a:rPr lang="en-US" sz="1250" dirty="0">
+                <a:solidFill>
+                  <a:srgbClr val="9DB4A9"/>
+                </a:solidFill>
+                <a:latin typeface="Calibri" pitchFamily="34" charset="0"/>
+                <a:ea typeface="Calibri" pitchFamily="34" charset="-122"/>
+                <a:cs typeface="Calibri" pitchFamily="34" charset="-120"/>
+              </a:rPr>
+              <a:t>₹30.1k</a:t>
+            </a:r>
+            <a:endParaRPr lang="en-US" sz="1250" dirty="0"/>
+          </a:p>
+        </p:txBody>
+      </p:sp>
+      <p:sp>
+        <p:nvSpPr>
+          <p:cNvPr id="20" name="Text 17"/>
+          <p:cNvSpPr/>
+          <p:nvPr/>
+        </p:nvSpPr>
+        <p:spPr>
+          <a:xfrm>
+            <a:off x="8732520" y="5074920"/>
+            <a:ext cx="2834640" cy="320040"/>
+          </a:xfrm>
+          <a:prstGeom prst="rect">
+            <a:avLst/>
+          </a:prstGeom>
+          <a:noFill/>
+          <a:ln/>
+        </p:spPr>
+        <p:txBody>
+          <a:bodyPr wrap="square" rtlCol="0" anchor="ctr"/>
+          <a:lstStyle/>
+          <a:p>
+            <a:pPr indent="0" marL="0">
+              <a:buNone/>
+            </a:pPr>
+            <a:r>
+              <a:rPr lang="en-US" sz="950" i="1" dirty="0">
+                <a:solidFill>
+                  <a:srgbClr val="9DB4A9"/>
+                </a:solidFill>
+                <a:latin typeface="Calibri" pitchFamily="34" charset="0"/>
+                <a:ea typeface="Calibri" pitchFamily="34" charset="-122"/>
+                <a:cs typeface="Calibri" pitchFamily="34" charset="-120"/>
+              </a:rPr>
+              <a:t>EMI = on-road, 5-yr, ~9% (EV 8.55% green loan)</a:t>
+            </a:r>
+            <a:endParaRPr lang="en-US" sz="950" dirty="0"/>
+          </a:p>
+        </p:txBody>
+      </p:sp>
+      <p:sp>
+        <p:nvSpPr>
+          <p:cNvPr id="21" name="Shape 18"/>
+          <p:cNvSpPr/>
+          <p:nvPr/>
+        </p:nvSpPr>
+        <p:spPr>
+          <a:xfrm>
+            <a:off x="548640" y="5623560"/>
+            <a:ext cx="11109960" cy="658368"/>
+          </a:xfrm>
+          <a:prstGeom prst="roundRect">
+            <a:avLst>
+              <a:gd name="adj" fmla="val 11111"/>
+            </a:avLst>
+          </a:prstGeom>
+          <a:solidFill>
+            <a:srgbClr val="2E9E6B"/>
+          </a:solidFill>
+          <a:ln/>
+        </p:spPr>
+      </p:sp>
+      <p:sp>
+        <p:nvSpPr>
+          <p:cNvPr id="22" name="Text 19"/>
+          <p:cNvSpPr/>
+          <p:nvPr/>
+        </p:nvSpPr>
+        <p:spPr>
+          <a:xfrm>
+            <a:off x="868680" y="5623560"/>
+            <a:ext cx="10515600" cy="658368"/>
+          </a:xfrm>
+          <a:prstGeom prst="rect">
+            <a:avLst/>
+          </a:prstGeom>
+          <a:noFill/>
+          <a:ln/>
+        </p:spPr>
+        <p:txBody>
+          <a:bodyPr wrap="square" rtlCol="0" anchor="ctr"/>
+          <a:lstStyle/>
+          <a:p>
+            <a:pPr indent="0" marL="0">
+              <a:lnSpc>
+                <a:spcPct val="100000"/>
+              </a:lnSpc>
+              <a:buNone/>
+            </a:pPr>
+            <a:r>
+              <a:rPr lang="en-US" sz="1350" b="1" dirty="0">
+                <a:solidFill>
+                  <a:srgbClr val="FFFFFF"/>
+                </a:solidFill>
+                <a:latin typeface="Calibri" pitchFamily="34" charset="0"/>
+                <a:ea typeface="Calibri" pitchFamily="34" charset="-122"/>
+                <a:cs typeface="Calibri" pitchFamily="34" charset="-120"/>
+              </a:rPr>
+              <a:t>The crossover:  </a:t>
+            </a:r>
+            <a:pPr indent="0" marL="0">
+              <a:lnSpc>
+                <a:spcPct val="100000"/>
+              </a:lnSpc>
+              <a:buNone/>
+            </a:pPr>
+            <a:r>
+              <a:rPr lang="en-US" sz="1350" dirty="0">
+                <a:solidFill>
+                  <a:srgbClr val="EAF6EF"/>
+                </a:solidFill>
+                <a:latin typeface="Calibri" pitchFamily="34" charset="0"/>
+                <a:ea typeface="Calibri" pitchFamily="34" charset="-122"/>
+                <a:cs typeface="Calibri" pitchFamily="34" charset="-120"/>
+              </a:rPr>
+              <a:t>at 12,000 km/yr, CNG wins and EV ≈ petrol — the EV's higher price offsets its cheap running. Above ~25,000 km/yr with home charging, the EV pulls clearly ahead.</a:t>
+            </a:r>
+            <a:endParaRPr lang="en-US" sz="1350" dirty="0"/>
+          </a:p>
+        </p:txBody>
+      </p:sp>
+      <p:sp>
+        <p:nvSpPr>
+          <p:cNvPr id="23" name="Text 20"/>
+          <p:cNvSpPr/>
+          <p:nvPr/>
+        </p:nvSpPr>
+        <p:spPr>
+          <a:xfrm>
+            <a:off x="548640" y="6473952"/>
+            <a:ext cx="11064240" cy="274320"/>
+          </a:xfrm>
+          <a:prstGeom prst="rect">
+            <a:avLst/>
+          </a:prstGeom>
+          <a:noFill/>
+          <a:ln/>
+        </p:spPr>
+        <p:txBody>
+          <a:bodyPr wrap="square" rtlCol="0" anchor="ctr"/>
+          <a:lstStyle/>
+          <a:p>
+            <a:pPr indent="0" marL="0">
+              <a:buNone/>
+            </a:pPr>
+            <a:r>
+              <a:rPr lang="en-US" sz="900" dirty="0">
+                <a:solidFill>
+                  <a:srgbClr val="5E6E66"/>
+                </a:solidFill>
+                <a:latin typeface="Calibri" pitchFamily="34" charset="0"/>
+                <a:ea typeface="Calibri" pitchFamily="34" charset="-122"/>
+                <a:cs typeface="Calibri" pitchFamily="34" charset="-120"/>
+              </a:rPr>
+              <a:t>Nexon on-road prices (CarWale/CarDekho, Jul 2026); Grand Vitara hybrid a segment up (~₹19.5L, ₹40.5k EMI). Loan rates SBI/HDFC 2026. EV resale ~40% is the key uncertainty.</a:t>
+            </a:r>
+            <a:endParaRPr lang="en-US" sz="900" dirty="0"/>
+          </a:p>
+        </p:txBody>
+      </p:sp>
+    </p:spTree>
+  </p:cSld>
+  <p:clrMapOvr>
+    <a:masterClrMapping/>
+  </p:clrMapOvr>
+</p:sld>
+</file>
+
+<file path=ppt/slides/slide8.xml><?xml version="1.0" encoding="utf-8"?>
+<p:sld xmlns:a="http://schemas.openxmlformats.org/drawingml/2006/main" xmlns:r="http://schemas.openxmlformats.org/officeDocument/2006/relationships" xmlns:p="http://schemas.openxmlformats.org/presentationml/2006/main">
+  <p:cSld name="Slide 8">
+    <p:bg>
+      <p:bgPr>
+        <a:solidFill>
           <a:srgbClr val="15271F"/>
         </a:solidFill>
       </p:bgPr>

</xml_diff>

<commit_message>
Add master deck (19 slides) + full-cost-stack slide in vehicle deck
- India_Fuel_Energy_Master.pptx: merges the three decks into one unified-palette
  brief — Part 1 exec summary, Part 2 buyer's guide, Part 3 policy case (19 slides).
- Vehicle deck: added 'full cost stack' slide (upfront on-road + EMI + insurance +
  road tax + maintenance + fuel = all-in/yr; CNG cheapest all-in when financed).

Co-Authored-By: Claude Opus 4.8 <noreply@anthropic.com>
</commit_message>
<xml_diff>
--- a/docs/India_Fuel_Vehicle_Choices_2026.pptx
+++ b/docs/India_Fuel_Vehicle_Choices_2026.pptx
@@ -13,9 +13,10 @@
     <p:sldId id="261" r:id="rId7"/>
     <p:sldId id="262" r:id="rId8"/>
     <p:sldId id="263" r:id="rId9"/>
+    <p:sldId id="264" r:id="rId10"/>
   </p:sldIdLst>
   <p:notesMasterIdLst>
-    <p:notesMasterId r:id="rId10"/>
+    <p:notesMasterId r:id="rId11"/>
   </p:notesMasterIdLst>
   <p:sldSz cx="12192000" cy="6858000"/>
   <p:notesSz cx="6858000" cy="12192000"/>
@@ -1806,6 +1807,94 @@
             <a:fld id="{F7021451-1387-4CA6-816F-3879F97B5CBC}" type="slidenum">
               <a:rPr lang="en-US"/>
               <a:t>8</a:t>
+            </a:fld>
+            <a:endParaRPr lang="en-US"/>
+          </a:p>
+        </p:txBody>
+      </p:sp>
+    </p:spTree>
+    <p:extLst>
+      <p:ext uri="{BB962C8B-B14F-4D97-AF65-F5344CB8AC3E}">
+        <p14:creationId xmlns:p14="http://schemas.microsoft.com/office/powerpoint/2010/main" val="1024086991"/>
+      </p:ext>
+    </p:extLst>
+  </p:cSld>
+  <p:clrMapOvr>
+    <a:masterClrMapping/>
+  </p:clrMapOvr>
+</p:notes>
+</file>
+
+<file path=ppt/notesSlides/notesSlide9.xml><?xml version="1.0" encoding="utf-8"?>
+<p:notes xmlns:a="http://schemas.openxmlformats.org/drawingml/2006/main" xmlns:r="http://schemas.openxmlformats.org/officeDocument/2006/relationships" xmlns:p="http://schemas.openxmlformats.org/presentationml/2006/main">
+  <p:cSld>
+    <p:spTree>
+      <p:nvGrpSpPr>
+        <p:cNvPr id="1" name=""/>
+        <p:cNvGrpSpPr/>
+        <p:nvPr/>
+      </p:nvGrpSpPr>
+      <p:grpSpPr>
+        <a:xfrm>
+          <a:off x="0" y="0"/>
+          <a:ext cx="0" cy="0"/>
+          <a:chOff x="0" y="0"/>
+          <a:chExt cx="0" cy="0"/>
+        </a:xfrm>
+      </p:grpSpPr>
+      <p:sp>
+        <p:nvSpPr>
+          <p:cNvPr id="2" name="Slide Image Placeholder 1"/>
+          <p:cNvSpPr>
+            <a:spLocks noGrp="1" noRot="1" noChangeAspect="1"/>
+          </p:cNvSpPr>
+          <p:nvPr>
+            <p:ph type="sldImg"/>
+          </p:nvPr>
+        </p:nvSpPr>
+        <p:spPr/>
+      </p:sp>
+      <p:sp>
+        <p:nvSpPr>
+          <p:cNvPr id="3" name="Notes Placeholder 2"/>
+          <p:cNvSpPr>
+            <a:spLocks noGrp="1"/>
+          </p:cNvSpPr>
+          <p:nvPr>
+            <p:ph type="body" idx="1"/>
+          </p:nvPr>
+        </p:nvSpPr>
+        <p:spPr/>
+        <p:txBody>
+          <a:bodyPr/>
+          <a:lstStyle/>
+          <a:p>
+            <a:r>
+              <a:rPr lang="en-US" dirty="0"/>
+              <a:t/>
+            </a:r>
+            <a:endParaRPr lang="en-US" dirty="0"/>
+          </a:p>
+        </p:txBody>
+      </p:sp>
+      <p:sp>
+        <p:nvSpPr>
+          <p:cNvPr id="4" name="Slide Number Placeholder 3"/>
+          <p:cNvSpPr>
+            <a:spLocks noGrp="1"/>
+          </p:cNvSpPr>
+          <p:nvPr>
+            <p:ph type="sldNum" sz="quarter" idx="10"/>
+          </p:nvPr>
+        </p:nvSpPr>
+        <p:spPr/>
+        <p:txBody>
+          <a:bodyPr/>
+          <a:lstStyle/>
+          <a:p>
+            <a:fld id="{F7021451-1387-4CA6-816F-3879F97B5CBC}" type="slidenum">
+              <a:rPr lang="en-US"/>
+              <a:t>9</a:t>
             </a:fld>
             <a:endParaRPr lang="en-US"/>
           </a:p>
@@ -8595,6 +8684,1866 @@
     <p:bg>
       <p:bgPr>
         <a:solidFill>
+          <a:srgbClr val="F7F9F7"/>
+        </a:solidFill>
+      </p:bgPr>
+    </p:bg>
+    <p:spTree>
+      <p:nvGrpSpPr>
+        <p:cNvPr id="1" name=""/>
+        <p:cNvGrpSpPr/>
+        <p:nvPr/>
+      </p:nvGrpSpPr>
+      <p:grpSpPr>
+        <a:xfrm>
+          <a:off x="0" y="0"/>
+          <a:ext cx="0" cy="0"/>
+          <a:chOff x="0" y="0"/>
+          <a:chExt cx="0" cy="0"/>
+        </a:xfrm>
+      </p:grpSpPr>
+      <p:sp>
+        <p:nvSpPr>
+          <p:cNvPr id="2" name="Text 0"/>
+          <p:cNvSpPr/>
+          <p:nvPr/>
+        </p:nvSpPr>
+        <p:spPr>
+          <a:xfrm>
+            <a:off x="548640" y="502920"/>
+            <a:ext cx="10058400" cy="274320"/>
+          </a:xfrm>
+          <a:prstGeom prst="rect">
+            <a:avLst/>
+          </a:prstGeom>
+          <a:noFill/>
+          <a:ln/>
+        </p:spPr>
+        <p:txBody>
+          <a:bodyPr wrap="square" rtlCol="0" anchor="ctr"/>
+          <a:lstStyle/>
+          <a:p>
+            <a:pPr indent="0" marL="0">
+              <a:buNone/>
+            </a:pPr>
+            <a:r>
+              <a:rPr lang="en-US" sz="1200" b="1" spc="300" kern="0" dirty="0">
+                <a:solidFill>
+                  <a:srgbClr val="2E8FA0"/>
+                </a:solidFill>
+                <a:latin typeface="Calibri" pitchFamily="34" charset="0"/>
+                <a:ea typeface="Calibri" pitchFamily="34" charset="-122"/>
+                <a:cs typeface="Calibri" pitchFamily="34" charset="-120"/>
+              </a:rPr>
+              <a:t>WHAT YOU ACTUALLY PAY</a:t>
+            </a:r>
+            <a:endParaRPr lang="en-US" sz="1200" dirty="0"/>
+          </a:p>
+        </p:txBody>
+      </p:sp>
+      <p:sp>
+        <p:nvSpPr>
+          <p:cNvPr id="3" name="Text 1"/>
+          <p:cNvSpPr/>
+          <p:nvPr/>
+        </p:nvSpPr>
+        <p:spPr>
+          <a:xfrm>
+            <a:off x="548640" y="777240"/>
+            <a:ext cx="10972800" cy="1005840"/>
+          </a:xfrm>
+          <a:prstGeom prst="rect">
+            <a:avLst/>
+          </a:prstGeom>
+          <a:noFill/>
+          <a:ln/>
+        </p:spPr>
+        <p:txBody>
+          <a:bodyPr wrap="square" rtlCol="0" anchor="ctr"/>
+          <a:lstStyle/>
+          <a:p>
+            <a:pPr indent="0" marL="0">
+              <a:lnSpc>
+                <a:spcPct val="98000"/>
+              </a:lnSpc>
+              <a:buNone/>
+            </a:pPr>
+            <a:r>
+              <a:rPr lang="en-US" sz="3400" b="1" dirty="0">
+                <a:solidFill>
+                  <a:srgbClr val="15271F"/>
+                </a:solidFill>
+                <a:latin typeface="Cambria" pitchFamily="34" charset="0"/>
+                <a:ea typeface="Cambria" pitchFamily="34" charset="-122"/>
+                <a:cs typeface="Cambria" pitchFamily="34" charset="-120"/>
+              </a:rPr>
+              <a:t>The full stack — upfront, fixed costs &amp; EMI</a:t>
+            </a:r>
+            <a:endParaRPr lang="en-US" sz="3400" dirty="0"/>
+          </a:p>
+        </p:txBody>
+      </p:sp>
+      <p:sp>
+        <p:nvSpPr>
+          <p:cNvPr id="4" name="Text 2"/>
+          <p:cNvSpPr/>
+          <p:nvPr/>
+        </p:nvSpPr>
+        <p:spPr>
+          <a:xfrm>
+            <a:off x="548640" y="1572768"/>
+            <a:ext cx="11064240" cy="365760"/>
+          </a:xfrm>
+          <a:prstGeom prst="rect">
+            <a:avLst/>
+          </a:prstGeom>
+          <a:noFill/>
+          <a:ln/>
+        </p:spPr>
+        <p:txBody>
+          <a:bodyPr wrap="square" rtlCol="0" anchor="ctr"/>
+          <a:lstStyle/>
+          <a:p>
+            <a:pPr indent="0" marL="0">
+              <a:buNone/>
+            </a:pPr>
+            <a:r>
+              <a:rPr lang="en-US" sz="1350" dirty="0">
+                <a:solidFill>
+                  <a:srgbClr val="5E6E66"/>
+                </a:solidFill>
+                <a:latin typeface="Calibri" pitchFamily="34" charset="0"/>
+                <a:ea typeface="Calibri" pitchFamily="34" charset="-122"/>
+                <a:cs typeface="Calibri" pitchFamily="34" charset="-120"/>
+              </a:rPr>
+              <a:t>Tata Nexon, on-road &amp; financed. Beyond fuel, a car costs you an EMI, insurance, road tax and upkeep.</a:t>
+            </a:r>
+            <a:endParaRPr lang="en-US" sz="1350" dirty="0"/>
+          </a:p>
+        </p:txBody>
+      </p:sp>
+      <p:sp>
+        <p:nvSpPr>
+          <p:cNvPr id="5" name="Shape 3"/>
+          <p:cNvSpPr/>
+          <p:nvPr/>
+        </p:nvSpPr>
+        <p:spPr>
+          <a:xfrm>
+            <a:off x="548640" y="2148840"/>
+            <a:ext cx="11064240" cy="566928"/>
+          </a:xfrm>
+          <a:prstGeom prst="roundRect">
+            <a:avLst>
+              <a:gd name="adj" fmla="val 8065"/>
+            </a:avLst>
+          </a:prstGeom>
+          <a:solidFill>
+            <a:srgbClr val="15271F"/>
+          </a:solidFill>
+          <a:ln w="12700">
+            <a:solidFill>
+              <a:srgbClr val="DCE4DF"/>
+            </a:solidFill>
+            <a:prstDash val="solid"/>
+          </a:ln>
+        </p:spPr>
+      </p:sp>
+      <p:sp>
+        <p:nvSpPr>
+          <p:cNvPr id="6" name="Text 4"/>
+          <p:cNvSpPr/>
+          <p:nvPr/>
+        </p:nvSpPr>
+        <p:spPr>
+          <a:xfrm>
+            <a:off x="685800" y="2148840"/>
+            <a:ext cx="1920240" cy="566928"/>
+          </a:xfrm>
+          <a:prstGeom prst="rect">
+            <a:avLst/>
+          </a:prstGeom>
+          <a:noFill/>
+          <a:ln/>
+        </p:spPr>
+        <p:txBody>
+          <a:bodyPr wrap="square" lIns="0" tIns="0" rIns="0" bIns="0" rtlCol="0" anchor="ctr"/>
+          <a:lstStyle/>
+          <a:p>
+            <a:pPr algn="l" indent="0" marL="0">
+              <a:buNone/>
+            </a:pPr>
+            <a:r>
+              <a:rPr lang="en-US" sz="1150" b="1" dirty="0">
+                <a:solidFill>
+                  <a:srgbClr val="FFFFFF"/>
+                </a:solidFill>
+                <a:latin typeface="Calibri" pitchFamily="34" charset="0"/>
+                <a:ea typeface="Calibri" pitchFamily="34" charset="-122"/>
+                <a:cs typeface="Calibri" pitchFamily="34" charset="-120"/>
+              </a:rPr>
+              <a:t>Fuel</a:t>
+            </a:r>
+            <a:endParaRPr lang="en-US" sz="1150" dirty="0"/>
+          </a:p>
+        </p:txBody>
+      </p:sp>
+      <p:sp>
+        <p:nvSpPr>
+          <p:cNvPr id="7" name="Text 5"/>
+          <p:cNvSpPr/>
+          <p:nvPr/>
+        </p:nvSpPr>
+        <p:spPr>
+          <a:xfrm>
+            <a:off x="2697480" y="2148840"/>
+            <a:ext cx="1371600" cy="566928"/>
+          </a:xfrm>
+          <a:prstGeom prst="rect">
+            <a:avLst/>
+          </a:prstGeom>
+          <a:noFill/>
+          <a:ln/>
+        </p:spPr>
+        <p:txBody>
+          <a:bodyPr wrap="square" lIns="0" tIns="0" rIns="0" bIns="0" rtlCol="0" anchor="ctr"/>
+          <a:lstStyle/>
+          <a:p>
+            <a:pPr algn="r" indent="0" marL="0">
+              <a:buNone/>
+            </a:pPr>
+            <a:r>
+              <a:rPr lang="en-US" sz="1150" b="1" dirty="0">
+                <a:solidFill>
+                  <a:srgbClr val="FFFFFF"/>
+                </a:solidFill>
+                <a:latin typeface="Calibri" pitchFamily="34" charset="0"/>
+                <a:ea typeface="Calibri" pitchFamily="34" charset="-122"/>
+                <a:cs typeface="Calibri" pitchFamily="34" charset="-120"/>
+              </a:rPr>
+              <a:t>On-road</a:t>
+            </a:r>
+            <a:endParaRPr lang="en-US" sz="1150" dirty="0"/>
+          </a:p>
+        </p:txBody>
+      </p:sp>
+      <p:sp>
+        <p:nvSpPr>
+          <p:cNvPr id="8" name="Text 6"/>
+          <p:cNvSpPr/>
+          <p:nvPr/>
+        </p:nvSpPr>
+        <p:spPr>
+          <a:xfrm>
+            <a:off x="4114800" y="2148840"/>
+            <a:ext cx="1371600" cy="566928"/>
+          </a:xfrm>
+          <a:prstGeom prst="rect">
+            <a:avLst/>
+          </a:prstGeom>
+          <a:noFill/>
+          <a:ln/>
+        </p:spPr>
+        <p:txBody>
+          <a:bodyPr wrap="square" lIns="0" tIns="0" rIns="0" bIns="0" rtlCol="0" anchor="ctr"/>
+          <a:lstStyle/>
+          <a:p>
+            <a:pPr algn="r" indent="0" marL="0">
+              <a:buNone/>
+            </a:pPr>
+            <a:r>
+              <a:rPr lang="en-US" sz="1150" b="1" dirty="0">
+                <a:solidFill>
+                  <a:srgbClr val="FFFFFF"/>
+                </a:solidFill>
+                <a:latin typeface="Calibri" pitchFamily="34" charset="0"/>
+                <a:ea typeface="Calibri" pitchFamily="34" charset="-122"/>
+                <a:cs typeface="Calibri" pitchFamily="34" charset="-120"/>
+              </a:rPr>
+              <a:t>EMI / mo</a:t>
+            </a:r>
+            <a:endParaRPr lang="en-US" sz="1150" dirty="0"/>
+          </a:p>
+        </p:txBody>
+      </p:sp>
+      <p:sp>
+        <p:nvSpPr>
+          <p:cNvPr id="9" name="Text 7"/>
+          <p:cNvSpPr/>
+          <p:nvPr/>
+        </p:nvSpPr>
+        <p:spPr>
+          <a:xfrm>
+            <a:off x="5532120" y="2148840"/>
+            <a:ext cx="1600200" cy="566928"/>
+          </a:xfrm>
+          <a:prstGeom prst="rect">
+            <a:avLst/>
+          </a:prstGeom>
+          <a:noFill/>
+          <a:ln/>
+        </p:spPr>
+        <p:txBody>
+          <a:bodyPr wrap="square" lIns="0" tIns="0" rIns="0" bIns="0" rtlCol="0" anchor="ctr"/>
+          <a:lstStyle/>
+          <a:p>
+            <a:pPr algn="r" indent="0" marL="0">
+              <a:buNone/>
+            </a:pPr>
+            <a:r>
+              <a:rPr lang="en-US" sz="1150" b="1" dirty="0">
+                <a:solidFill>
+                  <a:srgbClr val="FFFFFF"/>
+                </a:solidFill>
+                <a:latin typeface="Calibri" pitchFamily="34" charset="0"/>
+                <a:ea typeface="Calibri" pitchFamily="34" charset="-122"/>
+                <a:cs typeface="Calibri" pitchFamily="34" charset="-120"/>
+              </a:rPr>
+              <a:t>Insurance / yr</a:t>
+            </a:r>
+            <a:endParaRPr lang="en-US" sz="1150" dirty="0"/>
+          </a:p>
+        </p:txBody>
+      </p:sp>
+      <p:sp>
+        <p:nvSpPr>
+          <p:cNvPr id="10" name="Text 8"/>
+          <p:cNvSpPr/>
+          <p:nvPr/>
+        </p:nvSpPr>
+        <p:spPr>
+          <a:xfrm>
+            <a:off x="7178040" y="2148840"/>
+            <a:ext cx="1325880" cy="566928"/>
+          </a:xfrm>
+          <a:prstGeom prst="rect">
+            <a:avLst/>
+          </a:prstGeom>
+          <a:noFill/>
+          <a:ln/>
+        </p:spPr>
+        <p:txBody>
+          <a:bodyPr wrap="square" lIns="0" tIns="0" rIns="0" bIns="0" rtlCol="0" anchor="ctr"/>
+          <a:lstStyle/>
+          <a:p>
+            <a:pPr algn="r" indent="0" marL="0">
+              <a:buNone/>
+            </a:pPr>
+            <a:r>
+              <a:rPr lang="en-US" sz="1150" b="1" dirty="0">
+                <a:solidFill>
+                  <a:srgbClr val="FFFFFF"/>
+                </a:solidFill>
+                <a:latin typeface="Calibri" pitchFamily="34" charset="0"/>
+                <a:ea typeface="Calibri" pitchFamily="34" charset="-122"/>
+                <a:cs typeface="Calibri" pitchFamily="34" charset="-120"/>
+              </a:rPr>
+              <a:t>Maint / yr</a:t>
+            </a:r>
+            <a:endParaRPr lang="en-US" sz="1150" dirty="0"/>
+          </a:p>
+        </p:txBody>
+      </p:sp>
+      <p:sp>
+        <p:nvSpPr>
+          <p:cNvPr id="11" name="Text 9"/>
+          <p:cNvSpPr/>
+          <p:nvPr/>
+        </p:nvSpPr>
+        <p:spPr>
+          <a:xfrm>
+            <a:off x="8549640" y="2148840"/>
+            <a:ext cx="1280160" cy="566928"/>
+          </a:xfrm>
+          <a:prstGeom prst="rect">
+            <a:avLst/>
+          </a:prstGeom>
+          <a:noFill/>
+          <a:ln/>
+        </p:spPr>
+        <p:txBody>
+          <a:bodyPr wrap="square" lIns="0" tIns="0" rIns="0" bIns="0" rtlCol="0" anchor="ctr"/>
+          <a:lstStyle/>
+          <a:p>
+            <a:pPr algn="r" indent="0" marL="0">
+              <a:buNone/>
+            </a:pPr>
+            <a:r>
+              <a:rPr lang="en-US" sz="1150" b="1" dirty="0">
+                <a:solidFill>
+                  <a:srgbClr val="FFFFFF"/>
+                </a:solidFill>
+                <a:latin typeface="Calibri" pitchFamily="34" charset="0"/>
+                <a:ea typeface="Calibri" pitchFamily="34" charset="-122"/>
+                <a:cs typeface="Calibri" pitchFamily="34" charset="-120"/>
+              </a:rPr>
+              <a:t>Fuel / yr</a:t>
+            </a:r>
+            <a:endParaRPr lang="en-US" sz="1150" dirty="0"/>
+          </a:p>
+        </p:txBody>
+      </p:sp>
+      <p:sp>
+        <p:nvSpPr>
+          <p:cNvPr id="12" name="Text 10"/>
+          <p:cNvSpPr/>
+          <p:nvPr/>
+        </p:nvSpPr>
+        <p:spPr>
+          <a:xfrm>
+            <a:off x="9875520" y="2148840"/>
+            <a:ext cx="1371600" cy="566928"/>
+          </a:xfrm>
+          <a:prstGeom prst="rect">
+            <a:avLst/>
+          </a:prstGeom>
+          <a:noFill/>
+          <a:ln/>
+        </p:spPr>
+        <p:txBody>
+          <a:bodyPr wrap="square" lIns="0" tIns="0" rIns="0" bIns="0" rtlCol="0" anchor="ctr"/>
+          <a:lstStyle/>
+          <a:p>
+            <a:pPr algn="r" indent="0" marL="0">
+              <a:buNone/>
+            </a:pPr>
+            <a:r>
+              <a:rPr lang="en-US" sz="1150" b="1" dirty="0">
+                <a:solidFill>
+                  <a:srgbClr val="FFFFFF"/>
+                </a:solidFill>
+                <a:latin typeface="Calibri" pitchFamily="34" charset="0"/>
+                <a:ea typeface="Calibri" pitchFamily="34" charset="-122"/>
+                <a:cs typeface="Calibri" pitchFamily="34" charset="-120"/>
+              </a:rPr>
+              <a:t>All-in / yr</a:t>
+            </a:r>
+            <a:endParaRPr lang="en-US" sz="1150" dirty="0"/>
+          </a:p>
+        </p:txBody>
+      </p:sp>
+      <p:sp>
+        <p:nvSpPr>
+          <p:cNvPr id="13" name="Shape 11"/>
+          <p:cNvSpPr/>
+          <p:nvPr/>
+        </p:nvSpPr>
+        <p:spPr>
+          <a:xfrm>
+            <a:off x="548640" y="2807208"/>
+            <a:ext cx="11064240" cy="658368"/>
+          </a:xfrm>
+          <a:prstGeom prst="roundRect">
+            <a:avLst>
+              <a:gd name="adj" fmla="val 6944"/>
+            </a:avLst>
+          </a:prstGeom>
+          <a:solidFill>
+            <a:srgbClr val="FFFFFF"/>
+          </a:solidFill>
+          <a:ln w="12700">
+            <a:solidFill>
+              <a:srgbClr val="DCE4DF"/>
+            </a:solidFill>
+            <a:prstDash val="solid"/>
+          </a:ln>
+        </p:spPr>
+      </p:sp>
+      <p:sp>
+        <p:nvSpPr>
+          <p:cNvPr id="14" name="Shape 12"/>
+          <p:cNvSpPr/>
+          <p:nvPr/>
+        </p:nvSpPr>
+        <p:spPr>
+          <a:xfrm>
+            <a:off x="548640" y="2953512"/>
+            <a:ext cx="100584" cy="365760"/>
+          </a:xfrm>
+          <a:prstGeom prst="roundRect">
+            <a:avLst>
+              <a:gd name="adj" fmla="val 18182"/>
+            </a:avLst>
+          </a:prstGeom>
+          <a:solidFill>
+            <a:srgbClr val="D2892C"/>
+          </a:solidFill>
+          <a:ln/>
+        </p:spPr>
+      </p:sp>
+      <p:sp>
+        <p:nvSpPr>
+          <p:cNvPr id="15" name="Text 13"/>
+          <p:cNvSpPr/>
+          <p:nvPr/>
+        </p:nvSpPr>
+        <p:spPr>
+          <a:xfrm>
+            <a:off x="685800" y="2807208"/>
+            <a:ext cx="1920240" cy="658368"/>
+          </a:xfrm>
+          <a:prstGeom prst="rect">
+            <a:avLst/>
+          </a:prstGeom>
+          <a:noFill/>
+          <a:ln/>
+        </p:spPr>
+        <p:txBody>
+          <a:bodyPr wrap="square" lIns="0" tIns="0" rIns="0" bIns="0" rtlCol="0" anchor="ctr"/>
+          <a:lstStyle/>
+          <a:p>
+            <a:pPr algn="l" indent="0" marL="0">
+              <a:buNone/>
+            </a:pPr>
+            <a:r>
+              <a:rPr lang="en-US" sz="1350" b="1" dirty="0">
+                <a:solidFill>
+                  <a:srgbClr val="15271F"/>
+                </a:solidFill>
+                <a:latin typeface="Cambria" pitchFamily="34" charset="0"/>
+                <a:ea typeface="Cambria" pitchFamily="34" charset="-122"/>
+                <a:cs typeface="Cambria" pitchFamily="34" charset="-120"/>
+              </a:rPr>
+              <a:t>Petrol</a:t>
+            </a:r>
+            <a:endParaRPr lang="en-US" sz="1350" dirty="0"/>
+          </a:p>
+        </p:txBody>
+      </p:sp>
+      <p:sp>
+        <p:nvSpPr>
+          <p:cNvPr id="16" name="Text 14"/>
+          <p:cNvSpPr/>
+          <p:nvPr/>
+        </p:nvSpPr>
+        <p:spPr>
+          <a:xfrm>
+            <a:off x="2697480" y="2807208"/>
+            <a:ext cx="1371600" cy="658368"/>
+          </a:xfrm>
+          <a:prstGeom prst="rect">
+            <a:avLst/>
+          </a:prstGeom>
+          <a:noFill/>
+          <a:ln/>
+        </p:spPr>
+        <p:txBody>
+          <a:bodyPr wrap="square" lIns="0" tIns="0" rIns="0" bIns="0" rtlCol="0" anchor="ctr"/>
+          <a:lstStyle/>
+          <a:p>
+            <a:pPr algn="r" indent="0" marL="0">
+              <a:buNone/>
+            </a:pPr>
+            <a:r>
+              <a:rPr lang="en-US" sz="1350" dirty="0">
+                <a:solidFill>
+                  <a:srgbClr val="5E6E66"/>
+                </a:solidFill>
+                <a:latin typeface="Calibri" pitchFamily="34" charset="0"/>
+                <a:ea typeface="Calibri" pitchFamily="34" charset="-122"/>
+                <a:cs typeface="Calibri" pitchFamily="34" charset="-120"/>
+              </a:rPr>
+              <a:t>₹12.3L</a:t>
+            </a:r>
+            <a:endParaRPr lang="en-US" sz="1350" dirty="0"/>
+          </a:p>
+        </p:txBody>
+      </p:sp>
+      <p:sp>
+        <p:nvSpPr>
+          <p:cNvPr id="17" name="Text 15"/>
+          <p:cNvSpPr/>
+          <p:nvPr/>
+        </p:nvSpPr>
+        <p:spPr>
+          <a:xfrm>
+            <a:off x="4114800" y="2807208"/>
+            <a:ext cx="1371600" cy="658368"/>
+          </a:xfrm>
+          <a:prstGeom prst="rect">
+            <a:avLst/>
+          </a:prstGeom>
+          <a:noFill/>
+          <a:ln/>
+        </p:spPr>
+        <p:txBody>
+          <a:bodyPr wrap="square" lIns="0" tIns="0" rIns="0" bIns="0" rtlCol="0" anchor="ctr"/>
+          <a:lstStyle/>
+          <a:p>
+            <a:pPr algn="r" indent="0" marL="0">
+              <a:buNone/>
+            </a:pPr>
+            <a:r>
+              <a:rPr lang="en-US" sz="1350" dirty="0">
+                <a:solidFill>
+                  <a:srgbClr val="5E6E66"/>
+                </a:solidFill>
+                <a:latin typeface="Calibri" pitchFamily="34" charset="0"/>
+                <a:ea typeface="Calibri" pitchFamily="34" charset="-122"/>
+                <a:cs typeface="Calibri" pitchFamily="34" charset="-120"/>
+              </a:rPr>
+              <a:t>₹25.5k</a:t>
+            </a:r>
+            <a:endParaRPr lang="en-US" sz="1350" dirty="0"/>
+          </a:p>
+        </p:txBody>
+      </p:sp>
+      <p:sp>
+        <p:nvSpPr>
+          <p:cNvPr id="18" name="Text 16"/>
+          <p:cNvSpPr/>
+          <p:nvPr/>
+        </p:nvSpPr>
+        <p:spPr>
+          <a:xfrm>
+            <a:off x="5532120" y="2807208"/>
+            <a:ext cx="1600200" cy="658368"/>
+          </a:xfrm>
+          <a:prstGeom prst="rect">
+            <a:avLst/>
+          </a:prstGeom>
+          <a:noFill/>
+          <a:ln/>
+        </p:spPr>
+        <p:txBody>
+          <a:bodyPr wrap="square" lIns="0" tIns="0" rIns="0" bIns="0" rtlCol="0" anchor="ctr"/>
+          <a:lstStyle/>
+          <a:p>
+            <a:pPr algn="r" indent="0" marL="0">
+              <a:buNone/>
+            </a:pPr>
+            <a:r>
+              <a:rPr lang="en-US" sz="1350" dirty="0">
+                <a:solidFill>
+                  <a:srgbClr val="5E6E66"/>
+                </a:solidFill>
+                <a:latin typeface="Calibri" pitchFamily="34" charset="0"/>
+                <a:ea typeface="Calibri" pitchFamily="34" charset="-122"/>
+                <a:cs typeface="Calibri" pitchFamily="34" charset="-120"/>
+              </a:rPr>
+              <a:t>₹28k</a:t>
+            </a:r>
+            <a:endParaRPr lang="en-US" sz="1350" dirty="0"/>
+          </a:p>
+        </p:txBody>
+      </p:sp>
+      <p:sp>
+        <p:nvSpPr>
+          <p:cNvPr id="19" name="Text 17"/>
+          <p:cNvSpPr/>
+          <p:nvPr/>
+        </p:nvSpPr>
+        <p:spPr>
+          <a:xfrm>
+            <a:off x="7178040" y="2807208"/>
+            <a:ext cx="1325880" cy="658368"/>
+          </a:xfrm>
+          <a:prstGeom prst="rect">
+            <a:avLst/>
+          </a:prstGeom>
+          <a:noFill/>
+          <a:ln/>
+        </p:spPr>
+        <p:txBody>
+          <a:bodyPr wrap="square" lIns="0" tIns="0" rIns="0" bIns="0" rtlCol="0" anchor="ctr"/>
+          <a:lstStyle/>
+          <a:p>
+            <a:pPr algn="r" indent="0" marL="0">
+              <a:buNone/>
+            </a:pPr>
+            <a:r>
+              <a:rPr lang="en-US" sz="1350" dirty="0">
+                <a:solidFill>
+                  <a:srgbClr val="5E6E66"/>
+                </a:solidFill>
+                <a:latin typeface="Calibri" pitchFamily="34" charset="0"/>
+                <a:ea typeface="Calibri" pitchFamily="34" charset="-122"/>
+                <a:cs typeface="Calibri" pitchFamily="34" charset="-120"/>
+              </a:rPr>
+              <a:t>₹12k</a:t>
+            </a:r>
+            <a:endParaRPr lang="en-US" sz="1350" dirty="0"/>
+          </a:p>
+        </p:txBody>
+      </p:sp>
+      <p:sp>
+        <p:nvSpPr>
+          <p:cNvPr id="20" name="Text 18"/>
+          <p:cNvSpPr/>
+          <p:nvPr/>
+        </p:nvSpPr>
+        <p:spPr>
+          <a:xfrm>
+            <a:off x="8549640" y="2807208"/>
+            <a:ext cx="1280160" cy="658368"/>
+          </a:xfrm>
+          <a:prstGeom prst="rect">
+            <a:avLst/>
+          </a:prstGeom>
+          <a:noFill/>
+          <a:ln/>
+        </p:spPr>
+        <p:txBody>
+          <a:bodyPr wrap="square" lIns="0" tIns="0" rIns="0" bIns="0" rtlCol="0" anchor="ctr"/>
+          <a:lstStyle/>
+          <a:p>
+            <a:pPr algn="r" indent="0" marL="0">
+              <a:buNone/>
+            </a:pPr>
+            <a:r>
+              <a:rPr lang="en-US" sz="1350" dirty="0">
+                <a:solidFill>
+                  <a:srgbClr val="5E6E66"/>
+                </a:solidFill>
+                <a:latin typeface="Calibri" pitchFamily="34" charset="0"/>
+                <a:ea typeface="Calibri" pitchFamily="34" charset="-122"/>
+                <a:cs typeface="Calibri" pitchFamily="34" charset="-120"/>
+              </a:rPr>
+              <a:t>₹75k</a:t>
+            </a:r>
+            <a:endParaRPr lang="en-US" sz="1350" dirty="0"/>
+          </a:p>
+        </p:txBody>
+      </p:sp>
+      <p:sp>
+        <p:nvSpPr>
+          <p:cNvPr id="21" name="Text 19"/>
+          <p:cNvSpPr/>
+          <p:nvPr/>
+        </p:nvSpPr>
+        <p:spPr>
+          <a:xfrm>
+            <a:off x="9875520" y="2807208"/>
+            <a:ext cx="1371600" cy="658368"/>
+          </a:xfrm>
+          <a:prstGeom prst="rect">
+            <a:avLst/>
+          </a:prstGeom>
+          <a:noFill/>
+          <a:ln/>
+        </p:spPr>
+        <p:txBody>
+          <a:bodyPr wrap="square" lIns="0" tIns="0" rIns="0" bIns="0" rtlCol="0" anchor="ctr"/>
+          <a:lstStyle/>
+          <a:p>
+            <a:pPr algn="r" indent="0" marL="0">
+              <a:buNone/>
+            </a:pPr>
+            <a:r>
+              <a:rPr lang="en-US" sz="1500" b="1" dirty="0">
+                <a:solidFill>
+                  <a:srgbClr val="D2892C"/>
+                </a:solidFill>
+                <a:latin typeface="Cambria" pitchFamily="34" charset="0"/>
+                <a:ea typeface="Cambria" pitchFamily="34" charset="-122"/>
+                <a:cs typeface="Cambria" pitchFamily="34" charset="-120"/>
+              </a:rPr>
+              <a:t>₹4.21L</a:t>
+            </a:r>
+            <a:endParaRPr lang="en-US" sz="1500" dirty="0"/>
+          </a:p>
+        </p:txBody>
+      </p:sp>
+      <p:sp>
+        <p:nvSpPr>
+          <p:cNvPr id="22" name="Shape 20"/>
+          <p:cNvSpPr/>
+          <p:nvPr/>
+        </p:nvSpPr>
+        <p:spPr>
+          <a:xfrm>
+            <a:off x="548640" y="3447288"/>
+            <a:ext cx="11064240" cy="658368"/>
+          </a:xfrm>
+          <a:prstGeom prst="roundRect">
+            <a:avLst>
+              <a:gd name="adj" fmla="val 6944"/>
+            </a:avLst>
+          </a:prstGeom>
+          <a:solidFill>
+            <a:srgbClr val="FFFFFF"/>
+          </a:solidFill>
+          <a:ln w="12700">
+            <a:solidFill>
+              <a:srgbClr val="DCE4DF"/>
+            </a:solidFill>
+            <a:prstDash val="solid"/>
+          </a:ln>
+        </p:spPr>
+      </p:sp>
+      <p:sp>
+        <p:nvSpPr>
+          <p:cNvPr id="23" name="Shape 21"/>
+          <p:cNvSpPr/>
+          <p:nvPr/>
+        </p:nvSpPr>
+        <p:spPr>
+          <a:xfrm>
+            <a:off x="548640" y="3593592"/>
+            <a:ext cx="100584" cy="365760"/>
+          </a:xfrm>
+          <a:prstGeom prst="roundRect">
+            <a:avLst>
+              <a:gd name="adj" fmla="val 18182"/>
+            </a:avLst>
+          </a:prstGeom>
+          <a:solidFill>
+            <a:srgbClr val="2E8FA0"/>
+          </a:solidFill>
+          <a:ln/>
+        </p:spPr>
+      </p:sp>
+      <p:sp>
+        <p:nvSpPr>
+          <p:cNvPr id="24" name="Text 22"/>
+          <p:cNvSpPr/>
+          <p:nvPr/>
+        </p:nvSpPr>
+        <p:spPr>
+          <a:xfrm>
+            <a:off x="685800" y="3447288"/>
+            <a:ext cx="1920240" cy="658368"/>
+          </a:xfrm>
+          <a:prstGeom prst="rect">
+            <a:avLst/>
+          </a:prstGeom>
+          <a:noFill/>
+          <a:ln/>
+        </p:spPr>
+        <p:txBody>
+          <a:bodyPr wrap="square" lIns="0" tIns="0" rIns="0" bIns="0" rtlCol="0" anchor="ctr"/>
+          <a:lstStyle/>
+          <a:p>
+            <a:pPr algn="l" indent="0" marL="0">
+              <a:buNone/>
+            </a:pPr>
+            <a:r>
+              <a:rPr lang="en-US" sz="1350" b="1" dirty="0">
+                <a:solidFill>
+                  <a:srgbClr val="15271F"/>
+                </a:solidFill>
+                <a:latin typeface="Cambria" pitchFamily="34" charset="0"/>
+                <a:ea typeface="Cambria" pitchFamily="34" charset="-122"/>
+                <a:cs typeface="Cambria" pitchFamily="34" charset="-120"/>
+              </a:rPr>
+              <a:t>CNG</a:t>
+            </a:r>
+            <a:endParaRPr lang="en-US" sz="1350" dirty="0"/>
+          </a:p>
+        </p:txBody>
+      </p:sp>
+      <p:sp>
+        <p:nvSpPr>
+          <p:cNvPr id="25" name="Text 23"/>
+          <p:cNvSpPr/>
+          <p:nvPr/>
+        </p:nvSpPr>
+        <p:spPr>
+          <a:xfrm>
+            <a:off x="2697480" y="3447288"/>
+            <a:ext cx="1371600" cy="658368"/>
+          </a:xfrm>
+          <a:prstGeom prst="rect">
+            <a:avLst/>
+          </a:prstGeom>
+          <a:noFill/>
+          <a:ln/>
+        </p:spPr>
+        <p:txBody>
+          <a:bodyPr wrap="square" lIns="0" tIns="0" rIns="0" bIns="0" rtlCol="0" anchor="ctr"/>
+          <a:lstStyle/>
+          <a:p>
+            <a:pPr algn="r" indent="0" marL="0">
+              <a:buNone/>
+            </a:pPr>
+            <a:r>
+              <a:rPr lang="en-US" sz="1350" dirty="0">
+                <a:solidFill>
+                  <a:srgbClr val="5E6E66"/>
+                </a:solidFill>
+                <a:latin typeface="Calibri" pitchFamily="34" charset="0"/>
+                <a:ea typeface="Calibri" pitchFamily="34" charset="-122"/>
+                <a:cs typeface="Calibri" pitchFamily="34" charset="-120"/>
+              </a:rPr>
+              <a:t>₹13.3L</a:t>
+            </a:r>
+            <a:endParaRPr lang="en-US" sz="1350" dirty="0"/>
+          </a:p>
+        </p:txBody>
+      </p:sp>
+      <p:sp>
+        <p:nvSpPr>
+          <p:cNvPr id="26" name="Text 24"/>
+          <p:cNvSpPr/>
+          <p:nvPr/>
+        </p:nvSpPr>
+        <p:spPr>
+          <a:xfrm>
+            <a:off x="4114800" y="3447288"/>
+            <a:ext cx="1371600" cy="658368"/>
+          </a:xfrm>
+          <a:prstGeom prst="rect">
+            <a:avLst/>
+          </a:prstGeom>
+          <a:noFill/>
+          <a:ln/>
+        </p:spPr>
+        <p:txBody>
+          <a:bodyPr wrap="square" lIns="0" tIns="0" rIns="0" bIns="0" rtlCol="0" anchor="ctr"/>
+          <a:lstStyle/>
+          <a:p>
+            <a:pPr algn="r" indent="0" marL="0">
+              <a:buNone/>
+            </a:pPr>
+            <a:r>
+              <a:rPr lang="en-US" sz="1350" dirty="0">
+                <a:solidFill>
+                  <a:srgbClr val="5E6E66"/>
+                </a:solidFill>
+                <a:latin typeface="Calibri" pitchFamily="34" charset="0"/>
+                <a:ea typeface="Calibri" pitchFamily="34" charset="-122"/>
+                <a:cs typeface="Calibri" pitchFamily="34" charset="-120"/>
+              </a:rPr>
+              <a:t>₹27.6k</a:t>
+            </a:r>
+            <a:endParaRPr lang="en-US" sz="1350" dirty="0"/>
+          </a:p>
+        </p:txBody>
+      </p:sp>
+      <p:sp>
+        <p:nvSpPr>
+          <p:cNvPr id="27" name="Text 25"/>
+          <p:cNvSpPr/>
+          <p:nvPr/>
+        </p:nvSpPr>
+        <p:spPr>
+          <a:xfrm>
+            <a:off x="5532120" y="3447288"/>
+            <a:ext cx="1600200" cy="658368"/>
+          </a:xfrm>
+          <a:prstGeom prst="rect">
+            <a:avLst/>
+          </a:prstGeom>
+          <a:noFill/>
+          <a:ln/>
+        </p:spPr>
+        <p:txBody>
+          <a:bodyPr wrap="square" lIns="0" tIns="0" rIns="0" bIns="0" rtlCol="0" anchor="ctr"/>
+          <a:lstStyle/>
+          <a:p>
+            <a:pPr algn="r" indent="0" marL="0">
+              <a:buNone/>
+            </a:pPr>
+            <a:r>
+              <a:rPr lang="en-US" sz="1350" dirty="0">
+                <a:solidFill>
+                  <a:srgbClr val="5E6E66"/>
+                </a:solidFill>
+                <a:latin typeface="Calibri" pitchFamily="34" charset="0"/>
+                <a:ea typeface="Calibri" pitchFamily="34" charset="-122"/>
+                <a:cs typeface="Calibri" pitchFamily="34" charset="-120"/>
+              </a:rPr>
+              <a:t>₹29k</a:t>
+            </a:r>
+            <a:endParaRPr lang="en-US" sz="1350" dirty="0"/>
+          </a:p>
+        </p:txBody>
+      </p:sp>
+      <p:sp>
+        <p:nvSpPr>
+          <p:cNvPr id="28" name="Text 26"/>
+          <p:cNvSpPr/>
+          <p:nvPr/>
+        </p:nvSpPr>
+        <p:spPr>
+          <a:xfrm>
+            <a:off x="7178040" y="3447288"/>
+            <a:ext cx="1325880" cy="658368"/>
+          </a:xfrm>
+          <a:prstGeom prst="rect">
+            <a:avLst/>
+          </a:prstGeom>
+          <a:noFill/>
+          <a:ln/>
+        </p:spPr>
+        <p:txBody>
+          <a:bodyPr wrap="square" lIns="0" tIns="0" rIns="0" bIns="0" rtlCol="0" anchor="ctr"/>
+          <a:lstStyle/>
+          <a:p>
+            <a:pPr algn="r" indent="0" marL="0">
+              <a:buNone/>
+            </a:pPr>
+            <a:r>
+              <a:rPr lang="en-US" sz="1350" dirty="0">
+                <a:solidFill>
+                  <a:srgbClr val="5E6E66"/>
+                </a:solidFill>
+                <a:latin typeface="Calibri" pitchFamily="34" charset="0"/>
+                <a:ea typeface="Calibri" pitchFamily="34" charset="-122"/>
+                <a:cs typeface="Calibri" pitchFamily="34" charset="-120"/>
+              </a:rPr>
+              <a:t>₹14k</a:t>
+            </a:r>
+            <a:endParaRPr lang="en-US" sz="1350" dirty="0"/>
+          </a:p>
+        </p:txBody>
+      </p:sp>
+      <p:sp>
+        <p:nvSpPr>
+          <p:cNvPr id="29" name="Text 27"/>
+          <p:cNvSpPr/>
+          <p:nvPr/>
+        </p:nvSpPr>
+        <p:spPr>
+          <a:xfrm>
+            <a:off x="8549640" y="3447288"/>
+            <a:ext cx="1280160" cy="658368"/>
+          </a:xfrm>
+          <a:prstGeom prst="rect">
+            <a:avLst/>
+          </a:prstGeom>
+          <a:noFill/>
+          <a:ln/>
+        </p:spPr>
+        <p:txBody>
+          <a:bodyPr wrap="square" lIns="0" tIns="0" rIns="0" bIns="0" rtlCol="0" anchor="ctr"/>
+          <a:lstStyle/>
+          <a:p>
+            <a:pPr algn="r" indent="0" marL="0">
+              <a:buNone/>
+            </a:pPr>
+            <a:r>
+              <a:rPr lang="en-US" sz="1350" dirty="0">
+                <a:solidFill>
+                  <a:srgbClr val="5E6E66"/>
+                </a:solidFill>
+                <a:latin typeface="Calibri" pitchFamily="34" charset="0"/>
+                <a:ea typeface="Calibri" pitchFamily="34" charset="-122"/>
+                <a:cs typeface="Calibri" pitchFamily="34" charset="-120"/>
+              </a:rPr>
+              <a:t>₹38k</a:t>
+            </a:r>
+            <a:endParaRPr lang="en-US" sz="1350" dirty="0"/>
+          </a:p>
+        </p:txBody>
+      </p:sp>
+      <p:sp>
+        <p:nvSpPr>
+          <p:cNvPr id="30" name="Text 28"/>
+          <p:cNvSpPr/>
+          <p:nvPr/>
+        </p:nvSpPr>
+        <p:spPr>
+          <a:xfrm>
+            <a:off x="9875520" y="3447288"/>
+            <a:ext cx="1371600" cy="658368"/>
+          </a:xfrm>
+          <a:prstGeom prst="rect">
+            <a:avLst/>
+          </a:prstGeom>
+          <a:noFill/>
+          <a:ln/>
+        </p:spPr>
+        <p:txBody>
+          <a:bodyPr wrap="square" lIns="0" tIns="0" rIns="0" bIns="0" rtlCol="0" anchor="ctr"/>
+          <a:lstStyle/>
+          <a:p>
+            <a:pPr algn="r" indent="0" marL="0">
+              <a:buNone/>
+            </a:pPr>
+            <a:r>
+              <a:rPr lang="en-US" sz="1500" b="1" dirty="0">
+                <a:solidFill>
+                  <a:srgbClr val="2E8FA0"/>
+                </a:solidFill>
+                <a:latin typeface="Cambria" pitchFamily="34" charset="0"/>
+                <a:ea typeface="Cambria" pitchFamily="34" charset="-122"/>
+                <a:cs typeface="Cambria" pitchFamily="34" charset="-120"/>
+              </a:rPr>
+              <a:t>₹4.12L</a:t>
+            </a:r>
+            <a:endParaRPr lang="en-US" sz="1500" dirty="0"/>
+          </a:p>
+        </p:txBody>
+      </p:sp>
+      <p:sp>
+        <p:nvSpPr>
+          <p:cNvPr id="31" name="Shape 29"/>
+          <p:cNvSpPr/>
+          <p:nvPr/>
+        </p:nvSpPr>
+        <p:spPr>
+          <a:xfrm>
+            <a:off x="548640" y="4087368"/>
+            <a:ext cx="11064240" cy="658368"/>
+          </a:xfrm>
+          <a:prstGeom prst="roundRect">
+            <a:avLst>
+              <a:gd name="adj" fmla="val 6944"/>
+            </a:avLst>
+          </a:prstGeom>
+          <a:solidFill>
+            <a:srgbClr val="FFFFFF"/>
+          </a:solidFill>
+          <a:ln w="12700">
+            <a:solidFill>
+              <a:srgbClr val="DCE4DF"/>
+            </a:solidFill>
+            <a:prstDash val="solid"/>
+          </a:ln>
+        </p:spPr>
+      </p:sp>
+      <p:sp>
+        <p:nvSpPr>
+          <p:cNvPr id="32" name="Shape 30"/>
+          <p:cNvSpPr/>
+          <p:nvPr/>
+        </p:nvSpPr>
+        <p:spPr>
+          <a:xfrm>
+            <a:off x="548640" y="4233672"/>
+            <a:ext cx="100584" cy="365760"/>
+          </a:xfrm>
+          <a:prstGeom prst="roundRect">
+            <a:avLst>
+              <a:gd name="adj" fmla="val 18182"/>
+            </a:avLst>
+          </a:prstGeom>
+          <a:solidFill>
+            <a:srgbClr val="5D6E78"/>
+          </a:solidFill>
+          <a:ln/>
+        </p:spPr>
+      </p:sp>
+      <p:sp>
+        <p:nvSpPr>
+          <p:cNvPr id="33" name="Text 31"/>
+          <p:cNvSpPr/>
+          <p:nvPr/>
+        </p:nvSpPr>
+        <p:spPr>
+          <a:xfrm>
+            <a:off x="685800" y="4087368"/>
+            <a:ext cx="1920240" cy="658368"/>
+          </a:xfrm>
+          <a:prstGeom prst="rect">
+            <a:avLst/>
+          </a:prstGeom>
+          <a:noFill/>
+          <a:ln/>
+        </p:spPr>
+        <p:txBody>
+          <a:bodyPr wrap="square" lIns="0" tIns="0" rIns="0" bIns="0" rtlCol="0" anchor="ctr"/>
+          <a:lstStyle/>
+          <a:p>
+            <a:pPr algn="l" indent="0" marL="0">
+              <a:buNone/>
+            </a:pPr>
+            <a:r>
+              <a:rPr lang="en-US" sz="1350" b="1" dirty="0">
+                <a:solidFill>
+                  <a:srgbClr val="15271F"/>
+                </a:solidFill>
+                <a:latin typeface="Cambria" pitchFamily="34" charset="0"/>
+                <a:ea typeface="Cambria" pitchFamily="34" charset="-122"/>
+                <a:cs typeface="Cambria" pitchFamily="34" charset="-120"/>
+              </a:rPr>
+              <a:t>Diesel</a:t>
+            </a:r>
+            <a:endParaRPr lang="en-US" sz="1350" dirty="0"/>
+          </a:p>
+        </p:txBody>
+      </p:sp>
+      <p:sp>
+        <p:nvSpPr>
+          <p:cNvPr id="34" name="Text 32"/>
+          <p:cNvSpPr/>
+          <p:nvPr/>
+        </p:nvSpPr>
+        <p:spPr>
+          <a:xfrm>
+            <a:off x="2697480" y="4087368"/>
+            <a:ext cx="1371600" cy="658368"/>
+          </a:xfrm>
+          <a:prstGeom prst="rect">
+            <a:avLst/>
+          </a:prstGeom>
+          <a:noFill/>
+          <a:ln/>
+        </p:spPr>
+        <p:txBody>
+          <a:bodyPr wrap="square" lIns="0" tIns="0" rIns="0" bIns="0" rtlCol="0" anchor="ctr"/>
+          <a:lstStyle/>
+          <a:p>
+            <a:pPr algn="r" indent="0" marL="0">
+              <a:buNone/>
+            </a:pPr>
+            <a:r>
+              <a:rPr lang="en-US" sz="1350" dirty="0">
+                <a:solidFill>
+                  <a:srgbClr val="5E6E66"/>
+                </a:solidFill>
+                <a:latin typeface="Calibri" pitchFamily="34" charset="0"/>
+                <a:ea typeface="Calibri" pitchFamily="34" charset="-122"/>
+                <a:cs typeface="Calibri" pitchFamily="34" charset="-120"/>
+              </a:rPr>
+              <a:t>₹14.5L</a:t>
+            </a:r>
+            <a:endParaRPr lang="en-US" sz="1350" dirty="0"/>
+          </a:p>
+        </p:txBody>
+      </p:sp>
+      <p:sp>
+        <p:nvSpPr>
+          <p:cNvPr id="35" name="Text 33"/>
+          <p:cNvSpPr/>
+          <p:nvPr/>
+        </p:nvSpPr>
+        <p:spPr>
+          <a:xfrm>
+            <a:off x="4114800" y="4087368"/>
+            <a:ext cx="1371600" cy="658368"/>
+          </a:xfrm>
+          <a:prstGeom prst="rect">
+            <a:avLst/>
+          </a:prstGeom>
+          <a:noFill/>
+          <a:ln/>
+        </p:spPr>
+        <p:txBody>
+          <a:bodyPr wrap="square" lIns="0" tIns="0" rIns="0" bIns="0" rtlCol="0" anchor="ctr"/>
+          <a:lstStyle/>
+          <a:p>
+            <a:pPr algn="r" indent="0" marL="0">
+              <a:buNone/>
+            </a:pPr>
+            <a:r>
+              <a:rPr lang="en-US" sz="1350" dirty="0">
+                <a:solidFill>
+                  <a:srgbClr val="5E6E66"/>
+                </a:solidFill>
+                <a:latin typeface="Calibri" pitchFamily="34" charset="0"/>
+                <a:ea typeface="Calibri" pitchFamily="34" charset="-122"/>
+                <a:cs typeface="Calibri" pitchFamily="34" charset="-120"/>
+              </a:rPr>
+              <a:t>₹30.1k</a:t>
+            </a:r>
+            <a:endParaRPr lang="en-US" sz="1350" dirty="0"/>
+          </a:p>
+        </p:txBody>
+      </p:sp>
+      <p:sp>
+        <p:nvSpPr>
+          <p:cNvPr id="36" name="Text 34"/>
+          <p:cNvSpPr/>
+          <p:nvPr/>
+        </p:nvSpPr>
+        <p:spPr>
+          <a:xfrm>
+            <a:off x="5532120" y="4087368"/>
+            <a:ext cx="1600200" cy="658368"/>
+          </a:xfrm>
+          <a:prstGeom prst="rect">
+            <a:avLst/>
+          </a:prstGeom>
+          <a:noFill/>
+          <a:ln/>
+        </p:spPr>
+        <p:txBody>
+          <a:bodyPr wrap="square" lIns="0" tIns="0" rIns="0" bIns="0" rtlCol="0" anchor="ctr"/>
+          <a:lstStyle/>
+          <a:p>
+            <a:pPr algn="r" indent="0" marL="0">
+              <a:buNone/>
+            </a:pPr>
+            <a:r>
+              <a:rPr lang="en-US" sz="1350" dirty="0">
+                <a:solidFill>
+                  <a:srgbClr val="5E6E66"/>
+                </a:solidFill>
+                <a:latin typeface="Calibri" pitchFamily="34" charset="0"/>
+                <a:ea typeface="Calibri" pitchFamily="34" charset="-122"/>
+                <a:cs typeface="Calibri" pitchFamily="34" charset="-120"/>
+              </a:rPr>
+              <a:t>₹32k</a:t>
+            </a:r>
+            <a:endParaRPr lang="en-US" sz="1350" dirty="0"/>
+          </a:p>
+        </p:txBody>
+      </p:sp>
+      <p:sp>
+        <p:nvSpPr>
+          <p:cNvPr id="37" name="Text 35"/>
+          <p:cNvSpPr/>
+          <p:nvPr/>
+        </p:nvSpPr>
+        <p:spPr>
+          <a:xfrm>
+            <a:off x="7178040" y="4087368"/>
+            <a:ext cx="1325880" cy="658368"/>
+          </a:xfrm>
+          <a:prstGeom prst="rect">
+            <a:avLst/>
+          </a:prstGeom>
+          <a:noFill/>
+          <a:ln/>
+        </p:spPr>
+        <p:txBody>
+          <a:bodyPr wrap="square" lIns="0" tIns="0" rIns="0" bIns="0" rtlCol="0" anchor="ctr"/>
+          <a:lstStyle/>
+          <a:p>
+            <a:pPr algn="r" indent="0" marL="0">
+              <a:buNone/>
+            </a:pPr>
+            <a:r>
+              <a:rPr lang="en-US" sz="1350" dirty="0">
+                <a:solidFill>
+                  <a:srgbClr val="5E6E66"/>
+                </a:solidFill>
+                <a:latin typeface="Calibri" pitchFamily="34" charset="0"/>
+                <a:ea typeface="Calibri" pitchFamily="34" charset="-122"/>
+                <a:cs typeface="Calibri" pitchFamily="34" charset="-120"/>
+              </a:rPr>
+              <a:t>₹18k</a:t>
+            </a:r>
+            <a:endParaRPr lang="en-US" sz="1350" dirty="0"/>
+          </a:p>
+        </p:txBody>
+      </p:sp>
+      <p:sp>
+        <p:nvSpPr>
+          <p:cNvPr id="38" name="Text 36"/>
+          <p:cNvSpPr/>
+          <p:nvPr/>
+        </p:nvSpPr>
+        <p:spPr>
+          <a:xfrm>
+            <a:off x="8549640" y="4087368"/>
+            <a:ext cx="1280160" cy="658368"/>
+          </a:xfrm>
+          <a:prstGeom prst="rect">
+            <a:avLst/>
+          </a:prstGeom>
+          <a:noFill/>
+          <a:ln/>
+        </p:spPr>
+        <p:txBody>
+          <a:bodyPr wrap="square" lIns="0" tIns="0" rIns="0" bIns="0" rtlCol="0" anchor="ctr"/>
+          <a:lstStyle/>
+          <a:p>
+            <a:pPr algn="r" indent="0" marL="0">
+              <a:buNone/>
+            </a:pPr>
+            <a:r>
+              <a:rPr lang="en-US" sz="1350" dirty="0">
+                <a:solidFill>
+                  <a:srgbClr val="5E6E66"/>
+                </a:solidFill>
+                <a:latin typeface="Calibri" pitchFamily="34" charset="0"/>
+                <a:ea typeface="Calibri" pitchFamily="34" charset="-122"/>
+                <a:cs typeface="Calibri" pitchFamily="34" charset="-120"/>
+              </a:rPr>
+              <a:t>₹54k</a:t>
+            </a:r>
+            <a:endParaRPr lang="en-US" sz="1350" dirty="0"/>
+          </a:p>
+        </p:txBody>
+      </p:sp>
+      <p:sp>
+        <p:nvSpPr>
+          <p:cNvPr id="39" name="Text 37"/>
+          <p:cNvSpPr/>
+          <p:nvPr/>
+        </p:nvSpPr>
+        <p:spPr>
+          <a:xfrm>
+            <a:off x="9875520" y="4087368"/>
+            <a:ext cx="1371600" cy="658368"/>
+          </a:xfrm>
+          <a:prstGeom prst="rect">
+            <a:avLst/>
+          </a:prstGeom>
+          <a:noFill/>
+          <a:ln/>
+        </p:spPr>
+        <p:txBody>
+          <a:bodyPr wrap="square" lIns="0" tIns="0" rIns="0" bIns="0" rtlCol="0" anchor="ctr"/>
+          <a:lstStyle/>
+          <a:p>
+            <a:pPr algn="r" indent="0" marL="0">
+              <a:buNone/>
+            </a:pPr>
+            <a:r>
+              <a:rPr lang="en-US" sz="1500" b="1" dirty="0">
+                <a:solidFill>
+                  <a:srgbClr val="5D6E78"/>
+                </a:solidFill>
+                <a:latin typeface="Cambria" pitchFamily="34" charset="0"/>
+                <a:ea typeface="Cambria" pitchFamily="34" charset="-122"/>
+                <a:cs typeface="Cambria" pitchFamily="34" charset="-120"/>
+              </a:rPr>
+              <a:t>₹4.65L</a:t>
+            </a:r>
+            <a:endParaRPr lang="en-US" sz="1500" dirty="0"/>
+          </a:p>
+        </p:txBody>
+      </p:sp>
+      <p:sp>
+        <p:nvSpPr>
+          <p:cNvPr id="40" name="Shape 38"/>
+          <p:cNvSpPr/>
+          <p:nvPr/>
+        </p:nvSpPr>
+        <p:spPr>
+          <a:xfrm>
+            <a:off x="548640" y="4727448"/>
+            <a:ext cx="11064240" cy="658368"/>
+          </a:xfrm>
+          <a:prstGeom prst="roundRect">
+            <a:avLst>
+              <a:gd name="adj" fmla="val 6944"/>
+            </a:avLst>
+          </a:prstGeom>
+          <a:solidFill>
+            <a:srgbClr val="FFFFFF"/>
+          </a:solidFill>
+          <a:ln w="12700">
+            <a:solidFill>
+              <a:srgbClr val="DCE4DF"/>
+            </a:solidFill>
+            <a:prstDash val="solid"/>
+          </a:ln>
+        </p:spPr>
+      </p:sp>
+      <p:sp>
+        <p:nvSpPr>
+          <p:cNvPr id="41" name="Shape 39"/>
+          <p:cNvSpPr/>
+          <p:nvPr/>
+        </p:nvSpPr>
+        <p:spPr>
+          <a:xfrm>
+            <a:off x="548640" y="4873752"/>
+            <a:ext cx="100584" cy="365760"/>
+          </a:xfrm>
+          <a:prstGeom prst="roundRect">
+            <a:avLst>
+              <a:gd name="adj" fmla="val 18182"/>
+            </a:avLst>
+          </a:prstGeom>
+          <a:solidFill>
+            <a:srgbClr val="2E9E6B"/>
+          </a:solidFill>
+          <a:ln/>
+        </p:spPr>
+      </p:sp>
+      <p:sp>
+        <p:nvSpPr>
+          <p:cNvPr id="42" name="Text 40"/>
+          <p:cNvSpPr/>
+          <p:nvPr/>
+        </p:nvSpPr>
+        <p:spPr>
+          <a:xfrm>
+            <a:off x="685800" y="4727448"/>
+            <a:ext cx="1920240" cy="658368"/>
+          </a:xfrm>
+          <a:prstGeom prst="rect">
+            <a:avLst/>
+          </a:prstGeom>
+          <a:noFill/>
+          <a:ln/>
+        </p:spPr>
+        <p:txBody>
+          <a:bodyPr wrap="square" lIns="0" tIns="0" rIns="0" bIns="0" rtlCol="0" anchor="ctr"/>
+          <a:lstStyle/>
+          <a:p>
+            <a:pPr algn="l" indent="0" marL="0">
+              <a:buNone/>
+            </a:pPr>
+            <a:r>
+              <a:rPr lang="en-US" sz="1350" b="1" dirty="0">
+                <a:solidFill>
+                  <a:srgbClr val="15271F"/>
+                </a:solidFill>
+                <a:latin typeface="Cambria" pitchFamily="34" charset="0"/>
+                <a:ea typeface="Cambria" pitchFamily="34" charset="-122"/>
+                <a:cs typeface="Cambria" pitchFamily="34" charset="-120"/>
+              </a:rPr>
+              <a:t>EV (home)</a:t>
+            </a:r>
+            <a:endParaRPr lang="en-US" sz="1350" dirty="0"/>
+          </a:p>
+        </p:txBody>
+      </p:sp>
+      <p:sp>
+        <p:nvSpPr>
+          <p:cNvPr id="43" name="Text 41"/>
+          <p:cNvSpPr/>
+          <p:nvPr/>
+        </p:nvSpPr>
+        <p:spPr>
+          <a:xfrm>
+            <a:off x="2697480" y="4727448"/>
+            <a:ext cx="1371600" cy="658368"/>
+          </a:xfrm>
+          <a:prstGeom prst="rect">
+            <a:avLst/>
+          </a:prstGeom>
+          <a:noFill/>
+          <a:ln/>
+        </p:spPr>
+        <p:txBody>
+          <a:bodyPr wrap="square" lIns="0" tIns="0" rIns="0" bIns="0" rtlCol="0" anchor="ctr"/>
+          <a:lstStyle/>
+          <a:p>
+            <a:pPr algn="r" indent="0" marL="0">
+              <a:buNone/>
+            </a:pPr>
+            <a:r>
+              <a:rPr lang="en-US" sz="1350" dirty="0">
+                <a:solidFill>
+                  <a:srgbClr val="5E6E66"/>
+                </a:solidFill>
+                <a:latin typeface="Calibri" pitchFamily="34" charset="0"/>
+                <a:ea typeface="Calibri" pitchFamily="34" charset="-122"/>
+                <a:cs typeface="Calibri" pitchFamily="34" charset="-120"/>
+              </a:rPr>
+              <a:t>₹16.0L</a:t>
+            </a:r>
+            <a:endParaRPr lang="en-US" sz="1350" dirty="0"/>
+          </a:p>
+        </p:txBody>
+      </p:sp>
+      <p:sp>
+        <p:nvSpPr>
+          <p:cNvPr id="44" name="Text 42"/>
+          <p:cNvSpPr/>
+          <p:nvPr/>
+        </p:nvSpPr>
+        <p:spPr>
+          <a:xfrm>
+            <a:off x="4114800" y="4727448"/>
+            <a:ext cx="1371600" cy="658368"/>
+          </a:xfrm>
+          <a:prstGeom prst="rect">
+            <a:avLst/>
+          </a:prstGeom>
+          <a:noFill/>
+          <a:ln/>
+        </p:spPr>
+        <p:txBody>
+          <a:bodyPr wrap="square" lIns="0" tIns="0" rIns="0" bIns="0" rtlCol="0" anchor="ctr"/>
+          <a:lstStyle/>
+          <a:p>
+            <a:pPr algn="r" indent="0" marL="0">
+              <a:buNone/>
+            </a:pPr>
+            <a:r>
+              <a:rPr lang="en-US" sz="1350" dirty="0">
+                <a:solidFill>
+                  <a:srgbClr val="5E6E66"/>
+                </a:solidFill>
+                <a:latin typeface="Calibri" pitchFamily="34" charset="0"/>
+                <a:ea typeface="Calibri" pitchFamily="34" charset="-122"/>
+                <a:cs typeface="Calibri" pitchFamily="34" charset="-120"/>
+              </a:rPr>
+              <a:t>₹32.9k</a:t>
+            </a:r>
+            <a:endParaRPr lang="en-US" sz="1350" dirty="0"/>
+          </a:p>
+        </p:txBody>
+      </p:sp>
+      <p:sp>
+        <p:nvSpPr>
+          <p:cNvPr id="45" name="Text 43"/>
+          <p:cNvSpPr/>
+          <p:nvPr/>
+        </p:nvSpPr>
+        <p:spPr>
+          <a:xfrm>
+            <a:off x="5532120" y="4727448"/>
+            <a:ext cx="1600200" cy="658368"/>
+          </a:xfrm>
+          <a:prstGeom prst="rect">
+            <a:avLst/>
+          </a:prstGeom>
+          <a:noFill/>
+          <a:ln/>
+        </p:spPr>
+        <p:txBody>
+          <a:bodyPr wrap="square" lIns="0" tIns="0" rIns="0" bIns="0" rtlCol="0" anchor="ctr"/>
+          <a:lstStyle/>
+          <a:p>
+            <a:pPr algn="r" indent="0" marL="0">
+              <a:buNone/>
+            </a:pPr>
+            <a:r>
+              <a:rPr lang="en-US" sz="1350" dirty="0">
+                <a:solidFill>
+                  <a:srgbClr val="5E6E66"/>
+                </a:solidFill>
+                <a:latin typeface="Calibri" pitchFamily="34" charset="0"/>
+                <a:ea typeface="Calibri" pitchFamily="34" charset="-122"/>
+                <a:cs typeface="Calibri" pitchFamily="34" charset="-120"/>
+              </a:rPr>
+              <a:t>₹38k</a:t>
+            </a:r>
+            <a:endParaRPr lang="en-US" sz="1350" dirty="0"/>
+          </a:p>
+        </p:txBody>
+      </p:sp>
+      <p:sp>
+        <p:nvSpPr>
+          <p:cNvPr id="46" name="Text 44"/>
+          <p:cNvSpPr/>
+          <p:nvPr/>
+        </p:nvSpPr>
+        <p:spPr>
+          <a:xfrm>
+            <a:off x="7178040" y="4727448"/>
+            <a:ext cx="1325880" cy="658368"/>
+          </a:xfrm>
+          <a:prstGeom prst="rect">
+            <a:avLst/>
+          </a:prstGeom>
+          <a:noFill/>
+          <a:ln/>
+        </p:spPr>
+        <p:txBody>
+          <a:bodyPr wrap="square" lIns="0" tIns="0" rIns="0" bIns="0" rtlCol="0" anchor="ctr"/>
+          <a:lstStyle/>
+          <a:p>
+            <a:pPr algn="r" indent="0" marL="0">
+              <a:buNone/>
+            </a:pPr>
+            <a:r>
+              <a:rPr lang="en-US" sz="1350" dirty="0">
+                <a:solidFill>
+                  <a:srgbClr val="5E6E66"/>
+                </a:solidFill>
+                <a:latin typeface="Calibri" pitchFamily="34" charset="0"/>
+                <a:ea typeface="Calibri" pitchFamily="34" charset="-122"/>
+                <a:cs typeface="Calibri" pitchFamily="34" charset="-120"/>
+              </a:rPr>
+              <a:t>₹6k</a:t>
+            </a:r>
+            <a:endParaRPr lang="en-US" sz="1350" dirty="0"/>
+          </a:p>
+        </p:txBody>
+      </p:sp>
+      <p:sp>
+        <p:nvSpPr>
+          <p:cNvPr id="47" name="Text 45"/>
+          <p:cNvSpPr/>
+          <p:nvPr/>
+        </p:nvSpPr>
+        <p:spPr>
+          <a:xfrm>
+            <a:off x="8549640" y="4727448"/>
+            <a:ext cx="1280160" cy="658368"/>
+          </a:xfrm>
+          <a:prstGeom prst="rect">
+            <a:avLst/>
+          </a:prstGeom>
+          <a:noFill/>
+          <a:ln/>
+        </p:spPr>
+        <p:txBody>
+          <a:bodyPr wrap="square" lIns="0" tIns="0" rIns="0" bIns="0" rtlCol="0" anchor="ctr"/>
+          <a:lstStyle/>
+          <a:p>
+            <a:pPr algn="r" indent="0" marL="0">
+              <a:buNone/>
+            </a:pPr>
+            <a:r>
+              <a:rPr lang="en-US" sz="1350" dirty="0">
+                <a:solidFill>
+                  <a:srgbClr val="5E6E66"/>
+                </a:solidFill>
+                <a:latin typeface="Calibri" pitchFamily="34" charset="0"/>
+                <a:ea typeface="Calibri" pitchFamily="34" charset="-122"/>
+                <a:cs typeface="Calibri" pitchFamily="34" charset="-120"/>
+              </a:rPr>
+              <a:t>₹14k</a:t>
+            </a:r>
+            <a:endParaRPr lang="en-US" sz="1350" dirty="0"/>
+          </a:p>
+        </p:txBody>
+      </p:sp>
+      <p:sp>
+        <p:nvSpPr>
+          <p:cNvPr id="48" name="Text 46"/>
+          <p:cNvSpPr/>
+          <p:nvPr/>
+        </p:nvSpPr>
+        <p:spPr>
+          <a:xfrm>
+            <a:off x="9875520" y="4727448"/>
+            <a:ext cx="1371600" cy="658368"/>
+          </a:xfrm>
+          <a:prstGeom prst="rect">
+            <a:avLst/>
+          </a:prstGeom>
+          <a:noFill/>
+          <a:ln/>
+        </p:spPr>
+        <p:txBody>
+          <a:bodyPr wrap="square" lIns="0" tIns="0" rIns="0" bIns="0" rtlCol="0" anchor="ctr"/>
+          <a:lstStyle/>
+          <a:p>
+            <a:pPr algn="r" indent="0" marL="0">
+              <a:buNone/>
+            </a:pPr>
+            <a:r>
+              <a:rPr lang="en-US" sz="1500" b="1" dirty="0">
+                <a:solidFill>
+                  <a:srgbClr val="2E9E6B"/>
+                </a:solidFill>
+                <a:latin typeface="Cambria" pitchFamily="34" charset="0"/>
+                <a:ea typeface="Cambria" pitchFamily="34" charset="-122"/>
+                <a:cs typeface="Cambria" pitchFamily="34" charset="-120"/>
+              </a:rPr>
+              <a:t>₹4.53L</a:t>
+            </a:r>
+            <a:endParaRPr lang="en-US" sz="1500" dirty="0"/>
+          </a:p>
+        </p:txBody>
+      </p:sp>
+      <p:sp>
+        <p:nvSpPr>
+          <p:cNvPr id="49" name="Shape 47"/>
+          <p:cNvSpPr/>
+          <p:nvPr/>
+        </p:nvSpPr>
+        <p:spPr>
+          <a:xfrm>
+            <a:off x="548640" y="5669280"/>
+            <a:ext cx="11064240" cy="658368"/>
+          </a:xfrm>
+          <a:prstGeom prst="roundRect">
+            <a:avLst>
+              <a:gd name="adj" fmla="val 11111"/>
+            </a:avLst>
+          </a:prstGeom>
+          <a:solidFill>
+            <a:srgbClr val="2E9E6B"/>
+          </a:solidFill>
+          <a:ln/>
+        </p:spPr>
+      </p:sp>
+      <p:sp>
+        <p:nvSpPr>
+          <p:cNvPr id="50" name="Text 48"/>
+          <p:cNvSpPr/>
+          <p:nvPr/>
+        </p:nvSpPr>
+        <p:spPr>
+          <a:xfrm>
+            <a:off x="868680" y="5669280"/>
+            <a:ext cx="10515600" cy="658368"/>
+          </a:xfrm>
+          <a:prstGeom prst="rect">
+            <a:avLst/>
+          </a:prstGeom>
+          <a:noFill/>
+          <a:ln/>
+        </p:spPr>
+        <p:txBody>
+          <a:bodyPr wrap="square" rtlCol="0" anchor="ctr"/>
+          <a:lstStyle/>
+          <a:p>
+            <a:pPr indent="0" marL="0">
+              <a:lnSpc>
+                <a:spcPct val="100000"/>
+              </a:lnSpc>
+              <a:buNone/>
+            </a:pPr>
+            <a:r>
+              <a:rPr lang="en-US" sz="1300" b="1" dirty="0">
+                <a:solidFill>
+                  <a:srgbClr val="FFFFFF"/>
+                </a:solidFill>
+                <a:latin typeface="Calibri" pitchFamily="34" charset="0"/>
+                <a:ea typeface="Calibri" pitchFamily="34" charset="-122"/>
+                <a:cs typeface="Calibri" pitchFamily="34" charset="-120"/>
+              </a:rPr>
+              <a:t>Financed, </a:t>
+            </a:r>
+            <a:pPr indent="0" marL="0">
+              <a:lnSpc>
+                <a:spcPct val="100000"/>
+              </a:lnSpc>
+              <a:buNone/>
+            </a:pPr>
+            <a:r>
+              <a:rPr lang="en-US" sz="1300" dirty="0">
+                <a:solidFill>
+                  <a:srgbClr val="EAF6EF"/>
+                </a:solidFill>
+                <a:latin typeface="Calibri" pitchFamily="34" charset="0"/>
+                <a:ea typeface="Calibri" pitchFamily="34" charset="-122"/>
+                <a:cs typeface="Calibri" pitchFamily="34" charset="-120"/>
+              </a:rPr>
+              <a:t>the EV's cheap fuel doesn't cover its bigger EMI at 12,000 km/yr — CNG is cheapest all-in. EVs pay more insurance, but many states waive road tax (~₹1L off the on-road).</a:t>
+            </a:r>
+            <a:endParaRPr lang="en-US" sz="1300" dirty="0"/>
+          </a:p>
+        </p:txBody>
+      </p:sp>
+      <p:sp>
+        <p:nvSpPr>
+          <p:cNvPr id="51" name="Text 49"/>
+          <p:cNvSpPr/>
+          <p:nvPr/>
+        </p:nvSpPr>
+        <p:spPr>
+          <a:xfrm>
+            <a:off x="548640" y="6473952"/>
+            <a:ext cx="11064240" cy="274320"/>
+          </a:xfrm>
+          <a:prstGeom prst="rect">
+            <a:avLst/>
+          </a:prstGeom>
+          <a:noFill/>
+          <a:ln/>
+        </p:spPr>
+        <p:txBody>
+          <a:bodyPr wrap="square" rtlCol="0" anchor="ctr"/>
+          <a:lstStyle/>
+          <a:p>
+            <a:pPr indent="0" marL="0">
+              <a:buNone/>
+            </a:pPr>
+            <a:r>
+              <a:rPr lang="en-US" sz="900" dirty="0">
+                <a:solidFill>
+                  <a:srgbClr val="5E6E66"/>
+                </a:solidFill>
+                <a:latin typeface="Calibri" pitchFamily="34" charset="0"/>
+                <a:ea typeface="Calibri" pitchFamily="34" charset="-122"/>
+                <a:cs typeface="Calibri" pitchFamily="34" charset="-120"/>
+              </a:rPr>
+              <a:t>All-in/yr = EMI×12 + insurance + maintenance + fuel (excl. depreciation). EV on public charging ≈ ₹4.79L/yr. Prices/rates 2026.</a:t>
+            </a:r>
+            <a:endParaRPr lang="en-US" sz="900" dirty="0"/>
+          </a:p>
+        </p:txBody>
+      </p:sp>
+    </p:spTree>
+  </p:cSld>
+  <p:clrMapOvr>
+    <a:masterClrMapping/>
+  </p:clrMapOvr>
+</p:sld>
+</file>
+
+<file path=ppt/slides/slide9.xml><?xml version="1.0" encoding="utf-8"?>
+<p:sld xmlns:a="http://schemas.openxmlformats.org/drawingml/2006/main" xmlns:r="http://schemas.openxmlformats.org/officeDocument/2006/relationships" xmlns:p="http://schemas.openxmlformats.org/presentationml/2006/main">
+  <p:cSld name="Slide 9">
+    <p:bg>
+      <p:bgPr>
+        <a:solidFill>
           <a:srgbClr val="15271F"/>
         </a:solidFill>
       </p:bgPr>

</xml_diff>